<commit_message>
Prezentacja: nazwa zespołu DropTheBase
Co-Authored-By: Claude Opus 5.5 <noreply@anthropic.com>
</commit_message>
<xml_diff>
--- a/docs/pitch/Sztafeta-Slow.pptx
+++ b/docs/pitch/Sztafeta-Slow.pptx
@@ -116,28 +116,28 @@
   <p:extLst>
     <p:ext uri="{521415D9-36F7-43E2-AB2F-B90AF26B5E84}">
       <p14:sectionLst xmlns:p14="http://schemas.microsoft.com/office/powerpoint/2010/main">
-        <p14:section name="Problem" id="{ea1c25cf-ef00-df5d-e3b2-4d90d3b63e09}">
+        <p14:section name="Problem" id="{ee504379-e6ef-b864-69e8-248d459fd2a6}">
           <p14:sldIdLst>
             <p14:sldId id="256"/>
             <p14:sldId id="257"/>
             <p14:sldId id="258"/>
           </p14:sldIdLst>
         </p14:section>
-        <p14:section name="Rozwiązanie" id="{b357d167-f02f-f737-1a47-7cebdd8d2185}">
+        <p14:section name="Rozwiązanie" id="{ed0f0d65-f375-123d-9e27-a31481fb1fbf}">
           <p14:sldIdLst>
             <p14:sldId id="259"/>
             <p14:sldId id="260"/>
             <p14:sldId id="261"/>
           </p14:sldIdLst>
         </p14:section>
-        <p14:section name="Jak działa AI" id="{c3bcdbdc-9917-1fcb-43da-8e5fa8f76c54}">
+        <p14:section name="Jak działa AI" id="{5395a2f1-1880-e3ae-23df-aa6d37b36320}">
           <p14:sldIdLst>
             <p14:sldId id="262"/>
             <p14:sldId id="263"/>
             <p14:sldId id="264"/>
           </p14:sldIdLst>
         </p14:section>
-        <p14:section name="Zespół i demo" id="{12e25095-0651-ab32-e40e-352a2c334341}">
+        <p14:section name="Zespół i demo" id="{a8bdd21c-e3c4-87f8-d445-cd8c1c96a6a9}">
           <p14:sldIdLst>
             <p14:sldId id="265"/>
           </p14:sldIdLst>
@@ -1973,7 +1973,7 @@
                 <a:ea typeface="Arial" pitchFamily="34" charset="-122"/>
                 <a:cs typeface="Arial" pitchFamily="34" charset="-120"/>
               </a:rPr>
-              <a:t>Zespół Drop the Base</a:t>
+              <a:t>Zespół DropTheBase</a:t>
             </a:r>
             <a:endParaRPr lang="en-US" sz="1400" dirty="0"/>
           </a:p>
@@ -2111,7 +2111,7 @@
                 <a:ea typeface="Arial" pitchFamily="34" charset="-122"/>
                 <a:cs typeface="Arial" pitchFamily="34" charset="-120"/>
               </a:rPr>
-              <a:t>Zespół Drop the Base</a:t>
+              <a:t>Zespół DropTheBase</a:t>
             </a:r>
             <a:endParaRPr lang="en-US" sz="1800" dirty="0"/>
           </a:p>

</xml_diff>

<commit_message>
Prezentacja: większe telefony, slajd orkiestracji AI, bez nazw modeli
Co-Authored-By: Claude Opus 5.5 <noreply@anthropic.com>
</commit_message>
<xml_diff>
--- a/docs/pitch/Sztafeta-Slow.pptx
+++ b/docs/pitch/Sztafeta-Slow.pptx
@@ -116,28 +116,28 @@
   <p:extLst>
     <p:ext uri="{521415D9-36F7-43E2-AB2F-B90AF26B5E84}">
       <p14:sectionLst xmlns:p14="http://schemas.microsoft.com/office/powerpoint/2010/main">
-        <p14:section name="Problem" id="{ee504379-e6ef-b864-69e8-248d459fd2a6}">
+        <p14:section name="Problem" id="{640ef642-8def-861a-7a75-78dd1b5f25f4}">
           <p14:sldIdLst>
             <p14:sldId id="256"/>
             <p14:sldId id="257"/>
             <p14:sldId id="258"/>
           </p14:sldIdLst>
         </p14:section>
-        <p14:section name="Rozwiązanie" id="{ed0f0d65-f375-123d-9e27-a31481fb1fbf}">
+        <p14:section name="Rozwiązanie" id="{6b58cffb-2082-8389-57dc-8f9204f8ae78}">
           <p14:sldIdLst>
             <p14:sldId id="259"/>
             <p14:sldId id="260"/>
             <p14:sldId id="261"/>
           </p14:sldIdLst>
         </p14:section>
-        <p14:section name="Jak działa AI" id="{5395a2f1-1880-e3ae-23df-aa6d37b36320}">
+        <p14:section name="Jak działa AI" id="{920bffc1-159c-5425-2683-442c9034cb0f}">
           <p14:sldIdLst>
             <p14:sldId id="262"/>
             <p14:sldId id="263"/>
             <p14:sldId id="264"/>
           </p14:sldIdLst>
         </p14:section>
-        <p14:section name="Zespół i demo" id="{a8bdd21c-e3c4-87f8-d445-cd8c1c96a6a9}">
+        <p14:section name="Zespół i demo" id="{1c8b7a29-9629-9285-5dcd-0a3ad9dcd574}">
           <p14:sldIdLst>
             <p14:sldId id="265"/>
           </p14:sldIdLst>
@@ -1250,7 +1250,7 @@
           <a:p>
             <a:r>
               <a:rPr lang="en-US" dirty="0"/>
-              <a:t>Architektura jest celowo prosta: frontend React, backend FastAPI jako funkcja na Vercelu, modele na Groq, baza Postgres na Supabase. Dostawcę LLM zmienia się jedną zmienną środowiskową. Wszystkie odpowiedzi AI są walidowane schematem Pydantic; błędny JSON to jedno ponowienie, a bez sieci działa MockProvider.</a:t>
+              <a:t>Pod spodem to orkiestracja kilku kroków. Najpierw szybka lista słów w kodzie, bez LLM. Potem osobny model bezpieczeństwa łapie kontekst: przemoc, nękanie, dane osobowe. Recenzent ocenia zrozumienie i podaje cytat, który kod sprawdza dosłownie we wcześniejszym tekście. Na końcu narrator dopisuje ciąg dalszy. Każdy krok ma własny prompt w pliku, odpowiedź to JSON walidowany schematem z jednym ponowieniem, a dostawcę modeli zmienia się jedną zmienną środowiskową — Groq odpowiada w 1,5–2 sekundy.</a:t>
             </a:r>
             <a:endParaRPr lang="en-US" dirty="0"/>
           </a:p>
@@ -4893,7 +4893,7 @@
         </p:nvSpPr>
         <p:spPr>
           <a:xfrm>
-            <a:off x="812800" y="812800"/>
+            <a:off x="812800" y="1517650"/>
             <a:ext cx="10566400" cy="254000"/>
           </a:xfrm>
           <a:prstGeom prst="rect">
@@ -4935,8 +4935,8 @@
         </p:nvSpPr>
         <p:spPr>
           <a:xfrm>
-            <a:off x="812800" y="1333500"/>
-            <a:ext cx="10566400" cy="508000"/>
+            <a:off x="812800" y="1962150"/>
+            <a:ext cx="2667000" cy="1397000"/>
           </a:xfrm>
           <a:prstGeom prst="rect">
             <a:avLst/>
@@ -4971,29 +4971,112 @@
       </p:sp>
       <p:sp>
         <p:nvSpPr>
-          <p:cNvPr id="4" name="Shape 2"/>
+          <p:cNvPr id="4" name="Text 2"/>
           <p:cNvSpPr/>
           <p:nvPr/>
         </p:nvSpPr>
         <p:spPr>
           <a:xfrm>
-            <a:off x="1695450" y="2032000"/>
-            <a:ext cx="1663700" cy="3606800"/>
-          </a:xfrm>
-          <a:prstGeom prst="roundRect">
-            <a:avLst>
-              <a:gd name="adj" fmla="val 13740"/>
-            </a:avLst>
+            <a:off x="812800" y="4038600"/>
+            <a:ext cx="355600" cy="355600"/>
+          </a:xfrm>
+          <a:prstGeom prst="ellipse">
+            <a:avLst/>
           </a:prstGeom>
           <a:solidFill>
             <a:srgbClr val="1F2937"/>
           </a:solidFill>
           <a:ln/>
         </p:spPr>
+        <p:txBody>
+          <a:bodyPr wrap="square" lIns="0" tIns="0" rIns="0" bIns="0" rtlCol="0" anchor="ctr"/>
+          <a:lstStyle/>
+          <a:p>
+            <a:pPr algn="ctr" indent="0" marL="0">
+              <a:buNone/>
+            </a:pPr>
+            <a:r>
+              <a:rPr lang="en-US" sz="1400" b="1" dirty="0">
+                <a:solidFill>
+                  <a:srgbClr val="FFFFFF"/>
+                </a:solidFill>
+                <a:latin typeface="Arial" pitchFamily="34" charset="0"/>
+                <a:ea typeface="Arial" pitchFamily="34" charset="-122"/>
+                <a:cs typeface="Arial" pitchFamily="34" charset="-120"/>
+              </a:rPr>
+              <a:t>1</a:t>
+            </a:r>
+            <a:endParaRPr lang="en-US" sz="1400" dirty="0"/>
+          </a:p>
+        </p:txBody>
+      </p:sp>
+      <p:sp>
+        <p:nvSpPr>
+          <p:cNvPr id="5" name="Text 3"/>
+          <p:cNvSpPr txBox="1"/>
+          <p:nvPr/>
+        </p:nvSpPr>
+        <p:spPr>
+          <a:xfrm>
+            <a:off x="1295400" y="4038600"/>
+            <a:ext cx="2184400" cy="355600"/>
+          </a:xfrm>
+          <a:prstGeom prst="rect">
+            <a:avLst/>
+          </a:prstGeom>
+          <a:noFill/>
+          <a:ln/>
+        </p:spPr>
+        <p:txBody>
+          <a:bodyPr wrap="square" lIns="0" tIns="0" rIns="0" bIns="0" rtlCol="0" anchor="ctr"/>
+          <a:lstStyle/>
+          <a:p>
+            <a:pPr algn="l" indent="0" marL="0">
+              <a:lnSpc>
+                <a:spcPct val="110000"/>
+              </a:lnSpc>
+              <a:buNone/>
+            </a:pPr>
+            <a:r>
+              <a:rPr lang="en-US" sz="1400" b="1" dirty="0">
+                <a:solidFill>
+                  <a:srgbClr val="1F2937"/>
+                </a:solidFill>
+                <a:latin typeface="Arial" pitchFamily="34" charset="0"/>
+                <a:ea typeface="Arial" pitchFamily="34" charset="-122"/>
+                <a:cs typeface="Arial" pitchFamily="34" charset="-120"/>
+              </a:rPr>
+              <a:t>Czytasz i dopisujesz</a:t>
+            </a:r>
+            <a:endParaRPr lang="en-US" sz="1400" dirty="0"/>
+          </a:p>
+        </p:txBody>
+      </p:sp>
+      <p:sp>
+        <p:nvSpPr>
+          <p:cNvPr id="6" name="Shape 4"/>
+          <p:cNvSpPr/>
+          <p:nvPr/>
+        </p:nvSpPr>
+        <p:spPr>
+          <a:xfrm>
+            <a:off x="3981450" y="1016000"/>
+            <a:ext cx="2330450" cy="4826000"/>
+          </a:xfrm>
+          <a:prstGeom prst="roundRect">
+            <a:avLst>
+              <a:gd name="adj" fmla="val 9809"/>
+            </a:avLst>
+          </a:prstGeom>
+          <a:solidFill>
+            <a:srgbClr val="1F2937"/>
+          </a:solidFill>
+          <a:ln/>
+        </p:spPr>
       </p:sp>
       <p:pic>
         <p:nvPicPr>
-          <p:cNvPr id="5" name="Image 0" descr="preencoded.png">    </p:cNvPr>
+          <p:cNvPr id="7" name="Image 0" descr="preencoded.png">    </p:cNvPr>
           <p:cNvPicPr>
             <a:picLocks noChangeAspect="1"/>
           </p:cNvPicPr>
@@ -5007,8 +5090,8 @@
         </p:blipFill>
         <p:spPr>
           <a:xfrm>
-            <a:off x="1746250" y="2082800"/>
-            <a:ext cx="1562100" cy="3505200"/>
+            <a:off x="4032250" y="1066800"/>
+            <a:ext cx="2228850" cy="4724400"/>
           </a:xfrm>
           <a:prstGeom prst="rect">
             <a:avLst/>
@@ -5017,71 +5100,157 @@
       </p:pic>
       <p:sp>
         <p:nvSpPr>
-          <p:cNvPr id="6" name="Text 3"/>
-          <p:cNvSpPr txBox="1"/>
-          <p:nvPr/>
-        </p:nvSpPr>
-        <p:spPr>
-          <a:xfrm>
-            <a:off x="812800" y="5778500"/>
-            <a:ext cx="3429000" cy="266700"/>
-          </a:xfrm>
-          <a:prstGeom prst="rect">
-            <a:avLst/>
-          </a:prstGeom>
-          <a:noFill/>
-          <a:ln/>
-        </p:spPr>
-        <p:txBody>
-          <a:bodyPr wrap="square" lIns="0" tIns="0" rIns="0" bIns="0" rtlCol="0" anchor="t"/>
-          <a:lstStyle/>
-          <a:p>
-            <a:pPr algn="ctr" indent="0" marL="0">
-              <a:lnSpc>
-                <a:spcPct val="110000"/>
-              </a:lnSpc>
-              <a:buNone/>
-            </a:pPr>
-            <a:r>
-              <a:rPr lang="en-US" sz="1400" b="1" dirty="0">
-                <a:solidFill>
-                  <a:srgbClr val="1F2937"/>
-                </a:solidFill>
-                <a:latin typeface="Arial" pitchFamily="34" charset="0"/>
-                <a:ea typeface="Arial" pitchFamily="34" charset="-122"/>
-                <a:cs typeface="Arial" pitchFamily="34" charset="-120"/>
-              </a:rPr>
-              <a:t>1 · Czytasz i dopisujesz</a:t>
-            </a:r>
-            <a:endParaRPr lang="en-US" sz="1400" dirty="0"/>
-          </a:p>
-        </p:txBody>
-      </p:sp>
-      <p:sp>
-        <p:nvSpPr>
-          <p:cNvPr id="7" name="Shape 4"/>
+          <p:cNvPr id="8" name="Text 5"/>
           <p:cNvSpPr/>
           <p:nvPr/>
         </p:nvSpPr>
         <p:spPr>
           <a:xfrm>
-            <a:off x="5264150" y="2032000"/>
-            <a:ext cx="1663700" cy="3606800"/>
-          </a:xfrm>
-          <a:prstGeom prst="roundRect">
-            <a:avLst>
-              <a:gd name="adj" fmla="val 13740"/>
-            </a:avLst>
+            <a:off x="3829050" y="863600"/>
+            <a:ext cx="406400" cy="406400"/>
+          </a:xfrm>
+          <a:prstGeom prst="ellipse">
+            <a:avLst/>
           </a:prstGeom>
           <a:solidFill>
             <a:srgbClr val="1F2937"/>
           </a:solidFill>
+          <a:ln w="38100">
+            <a:solidFill>
+              <a:srgbClr val="FFF7ED"/>
+            </a:solidFill>
+          </a:ln>
+        </p:spPr>
+        <p:txBody>
+          <a:bodyPr wrap="square" lIns="0" tIns="0" rIns="0" bIns="0" rtlCol="0" anchor="ctr"/>
+          <a:lstStyle/>
+          <a:p>
+            <a:pPr algn="ctr" indent="0" marL="0">
+              <a:buNone/>
+            </a:pPr>
+            <a:r>
+              <a:rPr lang="en-US" sz="1600" b="1" dirty="0">
+                <a:solidFill>
+                  <a:srgbClr val="FFFFFF"/>
+                </a:solidFill>
+                <a:latin typeface="Arial" pitchFamily="34" charset="0"/>
+                <a:ea typeface="Arial" pitchFamily="34" charset="-122"/>
+                <a:cs typeface="Arial" pitchFamily="34" charset="-120"/>
+              </a:rPr>
+              <a:t>1</a:t>
+            </a:r>
+            <a:endParaRPr lang="en-US" sz="1600" dirty="0"/>
+          </a:p>
+        </p:txBody>
+      </p:sp>
+      <p:sp>
+        <p:nvSpPr>
+          <p:cNvPr id="9" name="Text 6"/>
+          <p:cNvSpPr/>
+          <p:nvPr/>
+        </p:nvSpPr>
+        <p:spPr>
+          <a:xfrm>
+            <a:off x="812800" y="4572000"/>
+            <a:ext cx="355600" cy="355600"/>
+          </a:xfrm>
+          <a:prstGeom prst="ellipse">
+            <a:avLst/>
+          </a:prstGeom>
+          <a:solidFill>
+            <a:srgbClr val="6D28D9"/>
+          </a:solidFill>
+          <a:ln/>
+        </p:spPr>
+        <p:txBody>
+          <a:bodyPr wrap="square" lIns="0" tIns="0" rIns="0" bIns="0" rtlCol="0" anchor="ctr"/>
+          <a:lstStyle/>
+          <a:p>
+            <a:pPr algn="ctr" indent="0" marL="0">
+              <a:buNone/>
+            </a:pPr>
+            <a:r>
+              <a:rPr lang="en-US" sz="1400" b="1" dirty="0">
+                <a:solidFill>
+                  <a:srgbClr val="FFFFFF"/>
+                </a:solidFill>
+                <a:latin typeface="Arial" pitchFamily="34" charset="0"/>
+                <a:ea typeface="Arial" pitchFamily="34" charset="-122"/>
+                <a:cs typeface="Arial" pitchFamily="34" charset="-120"/>
+              </a:rPr>
+              <a:t>2</a:t>
+            </a:r>
+            <a:endParaRPr lang="en-US" sz="1400" dirty="0"/>
+          </a:p>
+        </p:txBody>
+      </p:sp>
+      <p:sp>
+        <p:nvSpPr>
+          <p:cNvPr id="10" name="Text 7"/>
+          <p:cNvSpPr txBox="1"/>
+          <p:nvPr/>
+        </p:nvSpPr>
+        <p:spPr>
+          <a:xfrm>
+            <a:off x="1295400" y="4572000"/>
+            <a:ext cx="2184400" cy="355600"/>
+          </a:xfrm>
+          <a:prstGeom prst="rect">
+            <a:avLst/>
+          </a:prstGeom>
+          <a:noFill/>
+          <a:ln/>
+        </p:spPr>
+        <p:txBody>
+          <a:bodyPr wrap="square" lIns="0" tIns="0" rIns="0" bIns="0" rtlCol="0" anchor="ctr"/>
+          <a:lstStyle/>
+          <a:p>
+            <a:pPr algn="l" indent="0" marL="0">
+              <a:lnSpc>
+                <a:spcPct val="110000"/>
+              </a:lnSpc>
+              <a:buNone/>
+            </a:pPr>
+            <a:r>
+              <a:rPr lang="en-US" sz="1400" b="1" dirty="0">
+                <a:solidFill>
+                  <a:srgbClr val="6D28D9"/>
+                </a:solidFill>
+                <a:latin typeface="Arial" pitchFamily="34" charset="0"/>
+                <a:ea typeface="Arial" pitchFamily="34" charset="-122"/>
+                <a:cs typeface="Arial" pitchFamily="34" charset="-120"/>
+              </a:rPr>
+              <a:t>AI ocenia i pokazuje dowód</a:t>
+            </a:r>
+            <a:endParaRPr lang="en-US" sz="1400" dirty="0"/>
+          </a:p>
+        </p:txBody>
+      </p:sp>
+      <p:sp>
+        <p:nvSpPr>
+          <p:cNvPr id="11" name="Shape 8"/>
+          <p:cNvSpPr/>
+          <p:nvPr/>
+        </p:nvSpPr>
+        <p:spPr>
+          <a:xfrm>
+            <a:off x="6515100" y="1016000"/>
+            <a:ext cx="2330450" cy="4826000"/>
+          </a:xfrm>
+          <a:prstGeom prst="roundRect">
+            <a:avLst>
+              <a:gd name="adj" fmla="val 9809"/>
+            </a:avLst>
+          </a:prstGeom>
+          <a:solidFill>
+            <a:srgbClr val="1F2937"/>
+          </a:solidFill>
           <a:ln/>
         </p:spPr>
       </p:sp>
       <p:pic>
         <p:nvPicPr>
-          <p:cNvPr id="8" name="Image 1" descr="preencoded.png">    </p:cNvPr>
+          <p:cNvPr id="12" name="Image 1" descr="preencoded.png">    </p:cNvPr>
           <p:cNvPicPr>
             <a:picLocks noChangeAspect="1"/>
           </p:cNvPicPr>
@@ -5095,8 +5264,8 @@
         </p:blipFill>
         <p:spPr>
           <a:xfrm>
-            <a:off x="5314950" y="2082800"/>
-            <a:ext cx="1562100" cy="3505200"/>
+            <a:off x="6565900" y="1066800"/>
+            <a:ext cx="2228850" cy="4724400"/>
           </a:xfrm>
           <a:prstGeom prst="rect">
             <a:avLst/>
@@ -5105,26 +5274,112 @@
       </p:pic>
       <p:sp>
         <p:nvSpPr>
-          <p:cNvPr id="9" name="Text 5"/>
-          <p:cNvSpPr txBox="1"/>
-          <p:nvPr/>
-        </p:nvSpPr>
-        <p:spPr>
-          <a:xfrm>
-            <a:off x="4381500" y="5778500"/>
-            <a:ext cx="3429000" cy="266700"/>
-          </a:xfrm>
-          <a:prstGeom prst="rect">
-            <a:avLst/>
-          </a:prstGeom>
-          <a:noFill/>
-          <a:ln/>
-        </p:spPr>
-        <p:txBody>
-          <a:bodyPr wrap="square" lIns="0" tIns="0" rIns="0" bIns="0" rtlCol="0" anchor="t"/>
+          <p:cNvPr id="13" name="Text 9"/>
+          <p:cNvSpPr/>
+          <p:nvPr/>
+        </p:nvSpPr>
+        <p:spPr>
+          <a:xfrm>
+            <a:off x="6362700" y="863600"/>
+            <a:ext cx="406400" cy="406400"/>
+          </a:xfrm>
+          <a:prstGeom prst="ellipse">
+            <a:avLst/>
+          </a:prstGeom>
+          <a:solidFill>
+            <a:srgbClr val="6D28D9"/>
+          </a:solidFill>
+          <a:ln w="38100">
+            <a:solidFill>
+              <a:srgbClr val="FFF7ED"/>
+            </a:solidFill>
+          </a:ln>
+        </p:spPr>
+        <p:txBody>
+          <a:bodyPr wrap="square" lIns="0" tIns="0" rIns="0" bIns="0" rtlCol="0" anchor="ctr"/>
           <a:lstStyle/>
           <a:p>
             <a:pPr algn="ctr" indent="0" marL="0">
+              <a:buNone/>
+            </a:pPr>
+            <a:r>
+              <a:rPr lang="en-US" sz="1600" b="1" dirty="0">
+                <a:solidFill>
+                  <a:srgbClr val="FFFFFF"/>
+                </a:solidFill>
+                <a:latin typeface="Arial" pitchFamily="34" charset="0"/>
+                <a:ea typeface="Arial" pitchFamily="34" charset="-122"/>
+                <a:cs typeface="Arial" pitchFamily="34" charset="-120"/>
+              </a:rPr>
+              <a:t>2</a:t>
+            </a:r>
+            <a:endParaRPr lang="en-US" sz="1600" dirty="0"/>
+          </a:p>
+        </p:txBody>
+      </p:sp>
+      <p:sp>
+        <p:nvSpPr>
+          <p:cNvPr id="14" name="Text 10"/>
+          <p:cNvSpPr/>
+          <p:nvPr/>
+        </p:nvSpPr>
+        <p:spPr>
+          <a:xfrm>
+            <a:off x="812800" y="5105400"/>
+            <a:ext cx="355600" cy="355600"/>
+          </a:xfrm>
+          <a:prstGeom prst="ellipse">
+            <a:avLst/>
+          </a:prstGeom>
+          <a:solidFill>
+            <a:srgbClr val="B91C1C"/>
+          </a:solidFill>
+          <a:ln/>
+        </p:spPr>
+        <p:txBody>
+          <a:bodyPr wrap="square" lIns="0" tIns="0" rIns="0" bIns="0" rtlCol="0" anchor="ctr"/>
+          <a:lstStyle/>
+          <a:p>
+            <a:pPr algn="ctr" indent="0" marL="0">
+              <a:buNone/>
+            </a:pPr>
+            <a:r>
+              <a:rPr lang="en-US" sz="1400" b="1" dirty="0">
+                <a:solidFill>
+                  <a:srgbClr val="FFFFFF"/>
+                </a:solidFill>
+                <a:latin typeface="Arial" pitchFamily="34" charset="0"/>
+                <a:ea typeface="Arial" pitchFamily="34" charset="-122"/>
+                <a:cs typeface="Arial" pitchFamily="34" charset="-120"/>
+              </a:rPr>
+              <a:t>3</a:t>
+            </a:r>
+            <a:endParaRPr lang="en-US" sz="1400" dirty="0"/>
+          </a:p>
+        </p:txBody>
+      </p:sp>
+      <p:sp>
+        <p:nvSpPr>
+          <p:cNvPr id="15" name="Text 11"/>
+          <p:cNvSpPr txBox="1"/>
+          <p:nvPr/>
+        </p:nvSpPr>
+        <p:spPr>
+          <a:xfrm>
+            <a:off x="1295400" y="5105400"/>
+            <a:ext cx="2184400" cy="355600"/>
+          </a:xfrm>
+          <a:prstGeom prst="rect">
+            <a:avLst/>
+          </a:prstGeom>
+          <a:noFill/>
+          <a:ln/>
+        </p:spPr>
+        <p:txBody>
+          <a:bodyPr wrap="square" lIns="0" tIns="0" rIns="0" bIns="0" rtlCol="0" anchor="ctr"/>
+          <a:lstStyle/>
+          <a:p>
+            <a:pPr algn="l" indent="0" marL="0">
               <a:lnSpc>
                 <a:spcPct val="110000"/>
               </a:lnSpc>
@@ -5133,13 +5388,13 @@
             <a:r>
               <a:rPr lang="en-US" sz="1400" b="1" dirty="0">
                 <a:solidFill>
-                  <a:srgbClr val="6D28D9"/>
-                </a:solidFill>
-                <a:latin typeface="Arial" pitchFamily="34" charset="0"/>
-                <a:ea typeface="Arial" pitchFamily="34" charset="-122"/>
-                <a:cs typeface="Arial" pitchFamily="34" charset="-120"/>
-              </a:rPr>
-              <a:t>2 · AI ocenia i pokazuje dowód</a:t>
+                  <a:srgbClr val="B91C1C"/>
+                </a:solidFill>
+                <a:latin typeface="Arial" pitchFamily="34" charset="0"/>
+                <a:ea typeface="Arial" pitchFamily="34" charset="-122"/>
+                <a:cs typeface="Arial" pitchFamily="34" charset="-120"/>
+              </a:rPr>
+              <a:t>Moderacja zatrzymuje</a:t>
             </a:r>
             <a:endParaRPr lang="en-US" sz="1400" dirty="0"/>
           </a:p>
@@ -5147,18 +5402,18 @@
       </p:sp>
       <p:sp>
         <p:nvSpPr>
-          <p:cNvPr id="10" name="Shape 6"/>
+          <p:cNvPr id="16" name="Shape 12"/>
           <p:cNvSpPr/>
           <p:nvPr/>
         </p:nvSpPr>
         <p:spPr>
           <a:xfrm>
-            <a:off x="8832850" y="2032000"/>
-            <a:ext cx="1663700" cy="3606800"/>
+            <a:off x="9048750" y="1016000"/>
+            <a:ext cx="2330450" cy="4826000"/>
           </a:xfrm>
           <a:prstGeom prst="roundRect">
             <a:avLst>
-              <a:gd name="adj" fmla="val 13740"/>
+              <a:gd name="adj" fmla="val 9809"/>
             </a:avLst>
           </a:prstGeom>
           <a:solidFill>
@@ -5169,7 +5424,7 @@
       </p:sp>
       <p:pic>
         <p:nvPicPr>
-          <p:cNvPr id="11" name="Image 2" descr="preencoded.png">    </p:cNvPr>
+          <p:cNvPr id="17" name="Image 2" descr="preencoded.png">    </p:cNvPr>
           <p:cNvPicPr>
             <a:picLocks noChangeAspect="1"/>
           </p:cNvPicPr>
@@ -5183,8 +5438,8 @@
         </p:blipFill>
         <p:spPr>
           <a:xfrm>
-            <a:off x="8883650" y="2082800"/>
-            <a:ext cx="1562100" cy="3505200"/>
+            <a:off x="9099550" y="1066800"/>
+            <a:ext cx="2228850" cy="4724400"/>
           </a:xfrm>
           <a:prstGeom prst="rect">
             <a:avLst/>
@@ -5193,43 +5448,46 @@
       </p:pic>
       <p:sp>
         <p:nvSpPr>
-          <p:cNvPr id="12" name="Text 7"/>
-          <p:cNvSpPr txBox="1"/>
-          <p:nvPr/>
-        </p:nvSpPr>
-        <p:spPr>
-          <a:xfrm>
-            <a:off x="7950200" y="5778500"/>
-            <a:ext cx="3429000" cy="266700"/>
-          </a:xfrm>
-          <a:prstGeom prst="rect">
-            <a:avLst/>
-          </a:prstGeom>
-          <a:noFill/>
-          <a:ln/>
-        </p:spPr>
-        <p:txBody>
-          <a:bodyPr wrap="square" lIns="0" tIns="0" rIns="0" bIns="0" rtlCol="0" anchor="t"/>
+          <p:cNvPr id="18" name="Text 13"/>
+          <p:cNvSpPr/>
+          <p:nvPr/>
+        </p:nvSpPr>
+        <p:spPr>
+          <a:xfrm>
+            <a:off x="8896350" y="863600"/>
+            <a:ext cx="406400" cy="406400"/>
+          </a:xfrm>
+          <a:prstGeom prst="ellipse">
+            <a:avLst/>
+          </a:prstGeom>
+          <a:solidFill>
+            <a:srgbClr val="B91C1C"/>
+          </a:solidFill>
+          <a:ln w="38100">
+            <a:solidFill>
+              <a:srgbClr val="FFF7ED"/>
+            </a:solidFill>
+          </a:ln>
+        </p:spPr>
+        <p:txBody>
+          <a:bodyPr wrap="square" lIns="0" tIns="0" rIns="0" bIns="0" rtlCol="0" anchor="ctr"/>
           <a:lstStyle/>
           <a:p>
             <a:pPr algn="ctr" indent="0" marL="0">
-              <a:lnSpc>
-                <a:spcPct val="110000"/>
-              </a:lnSpc>
-              <a:buNone/>
-            </a:pPr>
-            <a:r>
-              <a:rPr lang="en-US" sz="1400" b="1" dirty="0">
-                <a:solidFill>
-                  <a:srgbClr val="B91C1C"/>
-                </a:solidFill>
-                <a:latin typeface="Arial" pitchFamily="34" charset="0"/>
-                <a:ea typeface="Arial" pitchFamily="34" charset="-122"/>
-                <a:cs typeface="Arial" pitchFamily="34" charset="-120"/>
-              </a:rPr>
-              <a:t>3 · Moderacja zatrzymuje</a:t>
-            </a:r>
-            <a:endParaRPr lang="en-US" sz="1400" dirty="0"/>
+              <a:buNone/>
+            </a:pPr>
+            <a:r>
+              <a:rPr lang="en-US" sz="1600" b="1" dirty="0">
+                <a:solidFill>
+                  <a:srgbClr val="FFFFFF"/>
+                </a:solidFill>
+                <a:latin typeface="Arial" pitchFamily="34" charset="0"/>
+                <a:ea typeface="Arial" pitchFamily="34" charset="-122"/>
+                <a:cs typeface="Arial" pitchFamily="34" charset="-120"/>
+              </a:rPr>
+              <a:t>3</a:t>
+            </a:r>
+            <a:endParaRPr lang="en-US" sz="1600" dirty="0"/>
           </a:p>
         </p:txBody>
       </p:sp>
@@ -5358,11 +5616,11 @@
         <p:spPr>
           <a:xfrm>
             <a:off x="812800" y="2667000"/>
-            <a:ext cx="3384550" cy="3302000"/>
+            <a:ext cx="3384550" cy="2984500"/>
           </a:xfrm>
           <a:prstGeom prst="roundRect">
             <a:avLst>
-              <a:gd name="adj" fmla="val 4615"/>
+              <a:gd name="adj" fmla="val 5106"/>
             </a:avLst>
           </a:prstGeom>
           <a:solidFill>
@@ -5486,60 +5744,18 @@
       </p:sp>
       <p:sp>
         <p:nvSpPr>
-          <p:cNvPr id="8" name="Text 5"/>
-          <p:cNvSpPr txBox="1"/>
-          <p:nvPr/>
-        </p:nvSpPr>
-        <p:spPr>
-          <a:xfrm>
-            <a:off x="1092200" y="5473700"/>
-            <a:ext cx="2825750" cy="215900"/>
-          </a:xfrm>
-          <a:prstGeom prst="rect">
-            <a:avLst/>
-          </a:prstGeom>
-          <a:noFill/>
-          <a:ln/>
-        </p:spPr>
-        <p:txBody>
-          <a:bodyPr wrap="square" lIns="0" tIns="0" rIns="0" bIns="0" rtlCol="0" anchor="t"/>
-          <a:lstStyle/>
-          <a:p>
-            <a:pPr algn="l" indent="0" marL="0">
-              <a:lnSpc>
-                <a:spcPct val="110000"/>
-              </a:lnSpc>
-              <a:buNone/>
-            </a:pPr>
-            <a:r>
-              <a:rPr lang="en-US" sz="1200" b="1" dirty="0">
-                <a:solidFill>
-                  <a:srgbClr val="6D28D9"/>
-                </a:solidFill>
-                <a:latin typeface="Arial" pitchFamily="34" charset="0"/>
-                <a:ea typeface="Arial" pitchFamily="34" charset="-122"/>
-                <a:cs typeface="Arial" pitchFamily="34" charset="-120"/>
-              </a:rPr>
-              <a:t>gpt-oss-safeguard-20b</a:t>
-            </a:r>
-            <a:endParaRPr lang="en-US" sz="1200" dirty="0"/>
-          </a:p>
-        </p:txBody>
-      </p:sp>
-      <p:sp>
-        <p:nvSpPr>
-          <p:cNvPr id="9" name="Shape 6"/>
+          <p:cNvPr id="8" name="Shape 5"/>
           <p:cNvSpPr/>
           <p:nvPr/>
         </p:nvSpPr>
         <p:spPr>
           <a:xfrm>
             <a:off x="4400550" y="2667000"/>
-            <a:ext cx="3384550" cy="3302000"/>
+            <a:ext cx="3384550" cy="2984500"/>
           </a:xfrm>
           <a:prstGeom prst="roundRect">
             <a:avLst>
-              <a:gd name="adj" fmla="val 4615"/>
+              <a:gd name="adj" fmla="val 5106"/>
             </a:avLst>
           </a:prstGeom>
           <a:solidFill>
@@ -5555,7 +5771,7 @@
       </p:sp>
       <p:pic>
         <p:nvPicPr>
-          <p:cNvPr id="10" name="Image 1" descr="preencoded.png">    </p:cNvPr>
+          <p:cNvPr id="9" name="Image 1" descr="preencoded.png">    </p:cNvPr>
           <p:cNvPicPr>
             <a:picLocks noChangeAspect="1"/>
           </p:cNvPicPr>
@@ -5579,7 +5795,7 @@
       </p:pic>
       <p:sp>
         <p:nvSpPr>
-          <p:cNvPr id="11" name="Text 7"/>
+          <p:cNvPr id="10" name="Text 6"/>
           <p:cNvSpPr txBox="1"/>
           <p:nvPr/>
         </p:nvSpPr>
@@ -5621,7 +5837,7 @@
       </p:sp>
       <p:sp>
         <p:nvSpPr>
-          <p:cNvPr id="12" name="Text 8"/>
+          <p:cNvPr id="11" name="Text 7"/>
           <p:cNvSpPr txBox="1"/>
           <p:nvPr/>
         </p:nvSpPr>
@@ -5663,60 +5879,18 @@
       </p:sp>
       <p:sp>
         <p:nvSpPr>
-          <p:cNvPr id="13" name="Text 9"/>
-          <p:cNvSpPr txBox="1"/>
-          <p:nvPr/>
-        </p:nvSpPr>
-        <p:spPr>
-          <a:xfrm>
-            <a:off x="4679950" y="5473700"/>
-            <a:ext cx="2825750" cy="215900"/>
-          </a:xfrm>
-          <a:prstGeom prst="rect">
-            <a:avLst/>
-          </a:prstGeom>
-          <a:noFill/>
-          <a:ln/>
-        </p:spPr>
-        <p:txBody>
-          <a:bodyPr wrap="square" lIns="0" tIns="0" rIns="0" bIns="0" rtlCol="0" anchor="t"/>
-          <a:lstStyle/>
-          <a:p>
-            <a:pPr algn="l" indent="0" marL="0">
-              <a:lnSpc>
-                <a:spcPct val="110000"/>
-              </a:lnSpc>
-              <a:buNone/>
-            </a:pPr>
-            <a:r>
-              <a:rPr lang="en-US" sz="1200" b="1" dirty="0">
-                <a:solidFill>
-                  <a:srgbClr val="6D28D9"/>
-                </a:solidFill>
-                <a:latin typeface="Arial" pitchFamily="34" charset="0"/>
-                <a:ea typeface="Arial" pitchFamily="34" charset="-122"/>
-                <a:cs typeface="Arial" pitchFamily="34" charset="-120"/>
-              </a:rPr>
-              <a:t>gpt-oss-120b</a:t>
-            </a:r>
-            <a:endParaRPr lang="en-US" sz="1200" dirty="0"/>
-          </a:p>
-        </p:txBody>
-      </p:sp>
-      <p:sp>
-        <p:nvSpPr>
-          <p:cNvPr id="14" name="Shape 10"/>
+          <p:cNvPr id="12" name="Shape 8"/>
           <p:cNvSpPr/>
           <p:nvPr/>
         </p:nvSpPr>
         <p:spPr>
           <a:xfrm>
             <a:off x="7988300" y="2667000"/>
-            <a:ext cx="3384550" cy="3302000"/>
+            <a:ext cx="3384550" cy="2984500"/>
           </a:xfrm>
           <a:prstGeom prst="roundRect">
             <a:avLst>
-              <a:gd name="adj" fmla="val 4615"/>
+              <a:gd name="adj" fmla="val 5106"/>
             </a:avLst>
           </a:prstGeom>
           <a:solidFill>
@@ -5732,7 +5906,7 @@
       </p:sp>
       <p:pic>
         <p:nvPicPr>
-          <p:cNvPr id="15" name="Image 2" descr="preencoded.png">    </p:cNvPr>
+          <p:cNvPr id="13" name="Image 2" descr="preencoded.png">    </p:cNvPr>
           <p:cNvPicPr>
             <a:picLocks noChangeAspect="1"/>
           </p:cNvPicPr>
@@ -5756,7 +5930,7 @@
       </p:pic>
       <p:sp>
         <p:nvSpPr>
-          <p:cNvPr id="16" name="Text 11"/>
+          <p:cNvPr id="14" name="Text 9"/>
           <p:cNvSpPr txBox="1"/>
           <p:nvPr/>
         </p:nvSpPr>
@@ -5798,7 +5972,7 @@
       </p:sp>
       <p:sp>
         <p:nvSpPr>
-          <p:cNvPr id="17" name="Text 12"/>
+          <p:cNvPr id="15" name="Text 10"/>
           <p:cNvSpPr txBox="1"/>
           <p:nvPr/>
         </p:nvSpPr>
@@ -5835,48 +6009,6 @@
               <a:t>Sprawdza nawiązanie do postaci, faktów i sytuacji — nie ortografię. Wynik 0–100, komentarz i cytat-dowód.</a:t>
             </a:r>
             <a:endParaRPr lang="en-US" sz="1400" dirty="0"/>
-          </a:p>
-        </p:txBody>
-      </p:sp>
-      <p:sp>
-        <p:nvSpPr>
-          <p:cNvPr id="18" name="Text 13"/>
-          <p:cNvSpPr txBox="1"/>
-          <p:nvPr/>
-        </p:nvSpPr>
-        <p:spPr>
-          <a:xfrm>
-            <a:off x="8267700" y="5473700"/>
-            <a:ext cx="2825750" cy="215900"/>
-          </a:xfrm>
-          <a:prstGeom prst="rect">
-            <a:avLst/>
-          </a:prstGeom>
-          <a:noFill/>
-          <a:ln/>
-        </p:spPr>
-        <p:txBody>
-          <a:bodyPr wrap="square" lIns="0" tIns="0" rIns="0" bIns="0" rtlCol="0" anchor="t"/>
-          <a:lstStyle/>
-          <a:p>
-            <a:pPr algn="l" indent="0" marL="0">
-              <a:lnSpc>
-                <a:spcPct val="110000"/>
-              </a:lnSpc>
-              <a:buNone/>
-            </a:pPr>
-            <a:r>
-              <a:rPr lang="en-US" sz="1200" b="1" dirty="0">
-                <a:solidFill>
-                  <a:srgbClr val="6D28D9"/>
-                </a:solidFill>
-                <a:latin typeface="Arial" pitchFamily="34" charset="0"/>
-                <a:ea typeface="Arial" pitchFamily="34" charset="-122"/>
-                <a:cs typeface="Arial" pitchFamily="34" charset="-120"/>
-              </a:rPr>
-              <a:t>gpt-oss-120b</a:t>
-            </a:r>
-            <a:endParaRPr lang="en-US" sz="1200" dirty="0"/>
           </a:p>
         </p:txBody>
       </p:sp>
@@ -5942,13 +6074,13 @@
             <a:r>
               <a:rPr lang="en-US" sz="1400" b="1" spc="200" kern="0" dirty="0">
                 <a:solidFill>
-                  <a:srgbClr val="C2410C"/>
-                </a:solidFill>
-                <a:latin typeface="Arial" pitchFamily="34" charset="0"/>
-                <a:ea typeface="Arial" pitchFamily="34" charset="-122"/>
-                <a:cs typeface="Arial" pitchFamily="34" charset="-120"/>
-              </a:rPr>
-              <a:t>ARCHITEKTURA</a:t>
+                  <a:srgbClr val="6D28D9"/>
+                </a:solidFill>
+                <a:latin typeface="Arial" pitchFamily="34" charset="0"/>
+                <a:ea typeface="Arial" pitchFamily="34" charset="-122"/>
+                <a:cs typeface="Arial" pitchFamily="34" charset="-120"/>
+              </a:rPr>
+              <a:t>ORKIESTRACJA AI</a:t>
             </a:r>
             <a:endParaRPr lang="en-US" sz="1400" dirty="0"/>
           </a:p>
@@ -5962,8 +6094,8 @@
         </p:nvSpPr>
         <p:spPr>
           <a:xfrm>
-            <a:off x="812800" y="1409700"/>
-            <a:ext cx="10566400" cy="1079500"/>
+            <a:off x="812800" y="1257300"/>
+            <a:ext cx="10566400" cy="571500"/>
           </a:xfrm>
           <a:prstGeom prst="rect">
             <a:avLst/>
@@ -5990,7 +6122,7 @@
                 <a:ea typeface="Arial" pitchFamily="34" charset="-122"/>
                 <a:cs typeface="Arial" pitchFamily="34" charset="-120"/>
               </a:rPr>
-              <a:t>Proste części, jeden adres dla wszystkich telefonów</a:t>
+              <a:t>Łańcuch AI dla każdego fragmentu</a:t>
             </a:r>
             <a:endParaRPr lang="en-US" sz="3600" dirty="0"/>
           </a:p>
@@ -6004,12 +6136,12 @@
         </p:nvSpPr>
         <p:spPr>
           <a:xfrm>
-            <a:off x="812800" y="2921000"/>
-            <a:ext cx="2336800" cy="1397000"/>
+            <a:off x="812800" y="2032000"/>
+            <a:ext cx="1778000" cy="2032000"/>
           </a:xfrm>
           <a:prstGeom prst="roundRect">
             <a:avLst>
-              <a:gd name="adj" fmla="val 10909"/>
+              <a:gd name="adj" fmla="val 8571"/>
             </a:avLst>
           </a:prstGeom>
           <a:solidFill>
@@ -6031,8 +6163,8 @@
         </p:nvSpPr>
         <p:spPr>
           <a:xfrm>
-            <a:off x="1041400" y="3149600"/>
-            <a:ext cx="1879600" cy="292100"/>
+            <a:off x="990600" y="2209800"/>
+            <a:ext cx="1422400" cy="203200"/>
           </a:xfrm>
           <a:prstGeom prst="rect">
             <a:avLst/>
@@ -6051,7 +6183,49 @@
               <a:buNone/>
             </a:pPr>
             <a:r>
-              <a:rPr lang="en-US" sz="1700" b="1" dirty="0">
+              <a:rPr lang="en-US" sz="1200" b="1" dirty="0">
+                <a:solidFill>
+                  <a:srgbClr val="C2410C"/>
+                </a:solidFill>
+                <a:latin typeface="Arial" pitchFamily="34" charset="0"/>
+                <a:ea typeface="Arial" pitchFamily="34" charset="-122"/>
+                <a:cs typeface="Arial" pitchFamily="34" charset="-120"/>
+              </a:rPr>
+              <a:t>1 · kod</a:t>
+            </a:r>
+            <a:endParaRPr lang="en-US" sz="1200" dirty="0"/>
+          </a:p>
+        </p:txBody>
+      </p:sp>
+      <p:sp>
+        <p:nvSpPr>
+          <p:cNvPr id="6" name="Text 4"/>
+          <p:cNvSpPr txBox="1"/>
+          <p:nvPr/>
+        </p:nvSpPr>
+        <p:spPr>
+          <a:xfrm>
+            <a:off x="990600" y="2476500"/>
+            <a:ext cx="1422400" cy="508000"/>
+          </a:xfrm>
+          <a:prstGeom prst="rect">
+            <a:avLst/>
+          </a:prstGeom>
+          <a:noFill/>
+          <a:ln/>
+        </p:spPr>
+        <p:txBody>
+          <a:bodyPr wrap="square" lIns="0" tIns="0" rIns="0" bIns="0" rtlCol="0" anchor="t"/>
+          <a:lstStyle/>
+          <a:p>
+            <a:pPr algn="l" indent="0" marL="0">
+              <a:lnSpc>
+                <a:spcPct val="110000"/>
+              </a:lnSpc>
+              <a:buNone/>
+            </a:pPr>
+            <a:r>
+              <a:rPr lang="en-US" sz="1600" b="1" dirty="0">
                 <a:solidFill>
                   <a:srgbClr val="1F2937"/>
                 </a:solidFill>
@@ -6059,41 +6233,41 @@
                 <a:ea typeface="Arial" pitchFamily="34" charset="-122"/>
                 <a:cs typeface="Arial" pitchFamily="34" charset="-120"/>
               </a:rPr>
-              <a:t>React + Vite</a:t>
-            </a:r>
-            <a:endParaRPr lang="en-US" sz="1700" dirty="0"/>
-          </a:p>
-        </p:txBody>
-      </p:sp>
-      <p:sp>
-        <p:nvSpPr>
-          <p:cNvPr id="6" name="Text 4"/>
-          <p:cNvSpPr txBox="1"/>
-          <p:nvPr/>
-        </p:nvSpPr>
-        <p:spPr>
-          <a:xfrm>
-            <a:off x="1041400" y="3530600"/>
-            <a:ext cx="1879600" cy="571500"/>
-          </a:xfrm>
-          <a:prstGeom prst="rect">
-            <a:avLst/>
-          </a:prstGeom>
-          <a:noFill/>
-          <a:ln/>
-        </p:spPr>
-        <p:txBody>
-          <a:bodyPr wrap="square" lIns="0" tIns="0" rIns="0" bIns="0" rtlCol="0" anchor="t"/>
-          <a:lstStyle/>
-          <a:p>
-            <a:pPr algn="l" indent="0" marL="0">
-              <a:lnSpc>
-                <a:spcPct val="125000"/>
-              </a:lnSpc>
-              <a:buNone/>
-            </a:pPr>
-            <a:r>
-              <a:rPr lang="en-US" sz="1300" dirty="0">
+              <a:t>Lista słów</a:t>
+            </a:r>
+            <a:endParaRPr lang="en-US" sz="1600" dirty="0"/>
+          </a:p>
+        </p:txBody>
+      </p:sp>
+      <p:sp>
+        <p:nvSpPr>
+          <p:cNvPr id="7" name="Text 5"/>
+          <p:cNvSpPr txBox="1"/>
+          <p:nvPr/>
+        </p:nvSpPr>
+        <p:spPr>
+          <a:xfrm>
+            <a:off x="990600" y="3098800"/>
+            <a:ext cx="1422400" cy="863600"/>
+          </a:xfrm>
+          <a:prstGeom prst="rect">
+            <a:avLst/>
+          </a:prstGeom>
+          <a:noFill/>
+          <a:ln/>
+        </p:spPr>
+        <p:txBody>
+          <a:bodyPr wrap="square" lIns="0" tIns="0" rIns="0" bIns="0" rtlCol="0" anchor="t"/>
+          <a:lstStyle/>
+          <a:p>
+            <a:pPr algn="l" indent="0" marL="0">
+              <a:lnSpc>
+                <a:spcPct val="120000"/>
+              </a:lnSpc>
+              <a:buNone/>
+            </a:pPr>
+            <a:r>
+              <a:rPr lang="en-US" sz="1200" dirty="0">
                 <a:solidFill>
                   <a:srgbClr val="4B5563"/>
                 </a:solidFill>
@@ -6101,15 +6275,15 @@
                 <a:ea typeface="Arial" pitchFamily="34" charset="-122"/>
                 <a:cs typeface="Arial" pitchFamily="34" charset="-120"/>
               </a:rPr>
-              <a:t>mobile-first, polling co 1,5 s</a:t>
-            </a:r>
-            <a:endParaRPr lang="en-US" sz="1300" dirty="0"/>
+              <a:t>polskie wulgaryzmy, bez LLM, 0,2 s</a:t>
+            </a:r>
+            <a:endParaRPr lang="en-US" sz="1200" dirty="0"/>
           </a:p>
         </p:txBody>
       </p:sp>
       <p:pic>
         <p:nvPicPr>
-          <p:cNvPr id="7" name="Image 0" descr="preencoded.png">    </p:cNvPr>
+          <p:cNvPr id="8" name="Image 0" descr="preencoded.png">    </p:cNvPr>
           <p:cNvPicPr>
             <a:picLocks noChangeAspect="1"/>
           </p:cNvPicPr>
@@ -6123,7 +6297,7 @@
         </p:blipFill>
         <p:spPr>
           <a:xfrm>
-            <a:off x="3225800" y="3492500"/>
+            <a:off x="2673350" y="2921000"/>
             <a:ext cx="254000" cy="254000"/>
           </a:xfrm>
           <a:prstGeom prst="rect">
@@ -6133,18 +6307,362 @@
       </p:pic>
       <p:sp>
         <p:nvSpPr>
-          <p:cNvPr id="8" name="Shape 5"/>
+          <p:cNvPr id="9" name="Shape 6"/>
           <p:cNvSpPr/>
           <p:nvPr/>
         </p:nvSpPr>
         <p:spPr>
           <a:xfrm>
-            <a:off x="3556000" y="2921000"/>
-            <a:ext cx="2336800" cy="1397000"/>
+            <a:off x="3009900" y="2032000"/>
+            <a:ext cx="1778000" cy="2032000"/>
           </a:xfrm>
           <a:prstGeom prst="roundRect">
             <a:avLst>
-              <a:gd name="adj" fmla="val 10909"/>
+              <a:gd name="adj" fmla="val 8571"/>
+            </a:avLst>
+          </a:prstGeom>
+          <a:solidFill>
+            <a:srgbClr val="F3E8FF"/>
+          </a:solidFill>
+          <a:ln/>
+        </p:spPr>
+      </p:sp>
+      <p:sp>
+        <p:nvSpPr>
+          <p:cNvPr id="10" name="Text 7"/>
+          <p:cNvSpPr txBox="1"/>
+          <p:nvPr/>
+        </p:nvSpPr>
+        <p:spPr>
+          <a:xfrm>
+            <a:off x="3187700" y="2209800"/>
+            <a:ext cx="1422400" cy="203200"/>
+          </a:xfrm>
+          <a:prstGeom prst="rect">
+            <a:avLst/>
+          </a:prstGeom>
+          <a:noFill/>
+          <a:ln/>
+        </p:spPr>
+        <p:txBody>
+          <a:bodyPr wrap="square" lIns="0" tIns="0" rIns="0" bIns="0" rtlCol="0" anchor="t"/>
+          <a:lstStyle/>
+          <a:p>
+            <a:pPr algn="l" indent="0" marL="0">
+              <a:lnSpc>
+                <a:spcPct val="110000"/>
+              </a:lnSpc>
+              <a:buNone/>
+            </a:pPr>
+            <a:r>
+              <a:rPr lang="en-US" sz="1200" b="1" dirty="0">
+                <a:solidFill>
+                  <a:srgbClr val="6D28D9"/>
+                </a:solidFill>
+                <a:latin typeface="Arial" pitchFamily="34" charset="0"/>
+                <a:ea typeface="Arial" pitchFamily="34" charset="-122"/>
+                <a:cs typeface="Arial" pitchFamily="34" charset="-120"/>
+              </a:rPr>
+              <a:t>2 · AI</a:t>
+            </a:r>
+            <a:endParaRPr lang="en-US" sz="1200" dirty="0"/>
+          </a:p>
+        </p:txBody>
+      </p:sp>
+      <p:sp>
+        <p:nvSpPr>
+          <p:cNvPr id="11" name="Text 8"/>
+          <p:cNvSpPr txBox="1"/>
+          <p:nvPr/>
+        </p:nvSpPr>
+        <p:spPr>
+          <a:xfrm>
+            <a:off x="3187700" y="2476500"/>
+            <a:ext cx="1422400" cy="508000"/>
+          </a:xfrm>
+          <a:prstGeom prst="rect">
+            <a:avLst/>
+          </a:prstGeom>
+          <a:noFill/>
+          <a:ln/>
+        </p:spPr>
+        <p:txBody>
+          <a:bodyPr wrap="square" lIns="0" tIns="0" rIns="0" bIns="0" rtlCol="0" anchor="t"/>
+          <a:lstStyle/>
+          <a:p>
+            <a:pPr algn="l" indent="0" marL="0">
+              <a:lnSpc>
+                <a:spcPct val="110000"/>
+              </a:lnSpc>
+              <a:buNone/>
+            </a:pPr>
+            <a:r>
+              <a:rPr lang="en-US" sz="1600" b="1" dirty="0">
+                <a:solidFill>
+                  <a:srgbClr val="1F2937"/>
+                </a:solidFill>
+                <a:latin typeface="Arial" pitchFamily="34" charset="0"/>
+                <a:ea typeface="Arial" pitchFamily="34" charset="-122"/>
+                <a:cs typeface="Arial" pitchFamily="34" charset="-120"/>
+              </a:rPr>
+              <a:t>Strażnik</a:t>
+            </a:r>
+            <a:endParaRPr lang="en-US" sz="1600" dirty="0"/>
+          </a:p>
+        </p:txBody>
+      </p:sp>
+      <p:sp>
+        <p:nvSpPr>
+          <p:cNvPr id="12" name="Text 9"/>
+          <p:cNvSpPr txBox="1"/>
+          <p:nvPr/>
+        </p:nvSpPr>
+        <p:spPr>
+          <a:xfrm>
+            <a:off x="3187700" y="3098800"/>
+            <a:ext cx="1422400" cy="863600"/>
+          </a:xfrm>
+          <a:prstGeom prst="rect">
+            <a:avLst/>
+          </a:prstGeom>
+          <a:noFill/>
+          <a:ln/>
+        </p:spPr>
+        <p:txBody>
+          <a:bodyPr wrap="square" lIns="0" tIns="0" rIns="0" bIns="0" rtlCol="0" anchor="t"/>
+          <a:lstStyle/>
+          <a:p>
+            <a:pPr algn="l" indent="0" marL="0">
+              <a:lnSpc>
+                <a:spcPct val="120000"/>
+              </a:lnSpc>
+              <a:buNone/>
+            </a:pPr>
+            <a:r>
+              <a:rPr lang="en-US" sz="1200" dirty="0">
+                <a:solidFill>
+                  <a:srgbClr val="4B5563"/>
+                </a:solidFill>
+                <a:latin typeface="Arial" pitchFamily="34" charset="0"/>
+                <a:ea typeface="Arial" pitchFamily="34" charset="-122"/>
+                <a:cs typeface="Arial" pitchFamily="34" charset="-120"/>
+              </a:rPr>
+              <a:t>model bezpieczeństwa: przemoc, nękanie, dane osobowe</a:t>
+            </a:r>
+            <a:endParaRPr lang="en-US" sz="1200" dirty="0"/>
+          </a:p>
+        </p:txBody>
+      </p:sp>
+      <p:pic>
+        <p:nvPicPr>
+          <p:cNvPr id="13" name="Image 1" descr="preencoded.png">    </p:cNvPr>
+          <p:cNvPicPr>
+            <a:picLocks noChangeAspect="1"/>
+          </p:cNvPicPr>
+          <p:nvPr/>
+        </p:nvPicPr>
+        <p:blipFill>
+          <a:blip r:embed="rId2"/>
+          <a:stretch>
+            <a:fillRect/>
+          </a:stretch>
+        </p:blipFill>
+        <p:spPr>
+          <a:xfrm>
+            <a:off x="4870450" y="2921000"/>
+            <a:ext cx="254000" cy="254000"/>
+          </a:xfrm>
+          <a:prstGeom prst="rect">
+            <a:avLst/>
+          </a:prstGeom>
+        </p:spPr>
+      </p:pic>
+      <p:sp>
+        <p:nvSpPr>
+          <p:cNvPr id="14" name="Shape 10"/>
+          <p:cNvSpPr/>
+          <p:nvPr/>
+        </p:nvSpPr>
+        <p:spPr>
+          <a:xfrm>
+            <a:off x="5207000" y="2032000"/>
+            <a:ext cx="1778000" cy="2032000"/>
+          </a:xfrm>
+          <a:prstGeom prst="roundRect">
+            <a:avLst>
+              <a:gd name="adj" fmla="val 8571"/>
+            </a:avLst>
+          </a:prstGeom>
+          <a:solidFill>
+            <a:srgbClr val="F3E8FF"/>
+          </a:solidFill>
+          <a:ln/>
+        </p:spPr>
+      </p:sp>
+      <p:sp>
+        <p:nvSpPr>
+          <p:cNvPr id="15" name="Text 11"/>
+          <p:cNvSpPr txBox="1"/>
+          <p:nvPr/>
+        </p:nvSpPr>
+        <p:spPr>
+          <a:xfrm>
+            <a:off x="5384800" y="2209800"/>
+            <a:ext cx="1422400" cy="203200"/>
+          </a:xfrm>
+          <a:prstGeom prst="rect">
+            <a:avLst/>
+          </a:prstGeom>
+          <a:noFill/>
+          <a:ln/>
+        </p:spPr>
+        <p:txBody>
+          <a:bodyPr wrap="square" lIns="0" tIns="0" rIns="0" bIns="0" rtlCol="0" anchor="t"/>
+          <a:lstStyle/>
+          <a:p>
+            <a:pPr algn="l" indent="0" marL="0">
+              <a:lnSpc>
+                <a:spcPct val="110000"/>
+              </a:lnSpc>
+              <a:buNone/>
+            </a:pPr>
+            <a:r>
+              <a:rPr lang="en-US" sz="1200" b="1" dirty="0">
+                <a:solidFill>
+                  <a:srgbClr val="6D28D9"/>
+                </a:solidFill>
+                <a:latin typeface="Arial" pitchFamily="34" charset="0"/>
+                <a:ea typeface="Arial" pitchFamily="34" charset="-122"/>
+                <a:cs typeface="Arial" pitchFamily="34" charset="-120"/>
+              </a:rPr>
+              <a:t>3 · AI</a:t>
+            </a:r>
+            <a:endParaRPr lang="en-US" sz="1200" dirty="0"/>
+          </a:p>
+        </p:txBody>
+      </p:sp>
+      <p:sp>
+        <p:nvSpPr>
+          <p:cNvPr id="16" name="Text 12"/>
+          <p:cNvSpPr txBox="1"/>
+          <p:nvPr/>
+        </p:nvSpPr>
+        <p:spPr>
+          <a:xfrm>
+            <a:off x="5384800" y="2476500"/>
+            <a:ext cx="1422400" cy="508000"/>
+          </a:xfrm>
+          <a:prstGeom prst="rect">
+            <a:avLst/>
+          </a:prstGeom>
+          <a:noFill/>
+          <a:ln/>
+        </p:spPr>
+        <p:txBody>
+          <a:bodyPr wrap="square" lIns="0" tIns="0" rIns="0" bIns="0" rtlCol="0" anchor="t"/>
+          <a:lstStyle/>
+          <a:p>
+            <a:pPr algn="l" indent="0" marL="0">
+              <a:lnSpc>
+                <a:spcPct val="110000"/>
+              </a:lnSpc>
+              <a:buNone/>
+            </a:pPr>
+            <a:r>
+              <a:rPr lang="en-US" sz="1600" b="1" dirty="0">
+                <a:solidFill>
+                  <a:srgbClr val="1F2937"/>
+                </a:solidFill>
+                <a:latin typeface="Arial" pitchFamily="34" charset="0"/>
+                <a:ea typeface="Arial" pitchFamily="34" charset="-122"/>
+                <a:cs typeface="Arial" pitchFamily="34" charset="-120"/>
+              </a:rPr>
+              <a:t>Recenzent</a:t>
+            </a:r>
+            <a:endParaRPr lang="en-US" sz="1600" dirty="0"/>
+          </a:p>
+        </p:txBody>
+      </p:sp>
+      <p:sp>
+        <p:nvSpPr>
+          <p:cNvPr id="17" name="Text 13"/>
+          <p:cNvSpPr txBox="1"/>
+          <p:nvPr/>
+        </p:nvSpPr>
+        <p:spPr>
+          <a:xfrm>
+            <a:off x="5384800" y="3098800"/>
+            <a:ext cx="1422400" cy="863600"/>
+          </a:xfrm>
+          <a:prstGeom prst="rect">
+            <a:avLst/>
+          </a:prstGeom>
+          <a:noFill/>
+          <a:ln/>
+        </p:spPr>
+        <p:txBody>
+          <a:bodyPr wrap="square" lIns="0" tIns="0" rIns="0" bIns="0" rtlCol="0" anchor="t"/>
+          <a:lstStyle/>
+          <a:p>
+            <a:pPr algn="l" indent="0" marL="0">
+              <a:lnSpc>
+                <a:spcPct val="120000"/>
+              </a:lnSpc>
+              <a:buNone/>
+            </a:pPr>
+            <a:r>
+              <a:rPr lang="en-US" sz="1200" dirty="0">
+                <a:solidFill>
+                  <a:srgbClr val="4B5563"/>
+                </a:solidFill>
+                <a:latin typeface="Arial" pitchFamily="34" charset="0"/>
+                <a:ea typeface="Arial" pitchFamily="34" charset="-122"/>
+                <a:cs typeface="Arial" pitchFamily="34" charset="-120"/>
+              </a:rPr>
+              <a:t>ocena zrozumienia 0–100 i cytat-dowód</a:t>
+            </a:r>
+            <a:endParaRPr lang="en-US" sz="1200" dirty="0"/>
+          </a:p>
+        </p:txBody>
+      </p:sp>
+      <p:pic>
+        <p:nvPicPr>
+          <p:cNvPr id="18" name="Image 2" descr="preencoded.png">    </p:cNvPr>
+          <p:cNvPicPr>
+            <a:picLocks noChangeAspect="1"/>
+          </p:cNvPicPr>
+          <p:nvPr/>
+        </p:nvPicPr>
+        <p:blipFill>
+          <a:blip r:embed="rId3"/>
+          <a:stretch>
+            <a:fillRect/>
+          </a:stretch>
+        </p:blipFill>
+        <p:spPr>
+          <a:xfrm>
+            <a:off x="7067550" y="2921000"/>
+            <a:ext cx="254000" cy="254000"/>
+          </a:xfrm>
+          <a:prstGeom prst="rect">
+            <a:avLst/>
+          </a:prstGeom>
+        </p:spPr>
+      </p:pic>
+      <p:sp>
+        <p:nvSpPr>
+          <p:cNvPr id="19" name="Shape 14"/>
+          <p:cNvSpPr/>
+          <p:nvPr/>
+        </p:nvSpPr>
+        <p:spPr>
+          <a:xfrm>
+            <a:off x="7404100" y="2032000"/>
+            <a:ext cx="1778000" cy="2032000"/>
+          </a:xfrm>
+          <a:prstGeom prst="roundRect">
+            <a:avLst>
+              <a:gd name="adj" fmla="val 8571"/>
             </a:avLst>
           </a:prstGeom>
           <a:solidFill>
@@ -6160,14 +6678,14 @@
       </p:sp>
       <p:sp>
         <p:nvSpPr>
-          <p:cNvPr id="9" name="Text 6"/>
-          <p:cNvSpPr txBox="1"/>
-          <p:nvPr/>
-        </p:nvSpPr>
-        <p:spPr>
-          <a:xfrm>
-            <a:off x="3784600" y="3149600"/>
-            <a:ext cx="1879600" cy="292100"/>
+          <p:cNvPr id="20" name="Text 15"/>
+          <p:cNvSpPr txBox="1"/>
+          <p:nvPr/>
+        </p:nvSpPr>
+        <p:spPr>
+          <a:xfrm>
+            <a:off x="7581900" y="2209800"/>
+            <a:ext cx="1422400" cy="203200"/>
           </a:xfrm>
           <a:prstGeom prst="rect">
             <a:avLst/>
@@ -6186,7 +6704,49 @@
               <a:buNone/>
             </a:pPr>
             <a:r>
-              <a:rPr lang="en-US" sz="1700" b="1" dirty="0">
+              <a:rPr lang="en-US" sz="1200" b="1" dirty="0">
+                <a:solidFill>
+                  <a:srgbClr val="C2410C"/>
+                </a:solidFill>
+                <a:latin typeface="Arial" pitchFamily="34" charset="0"/>
+                <a:ea typeface="Arial" pitchFamily="34" charset="-122"/>
+                <a:cs typeface="Arial" pitchFamily="34" charset="-120"/>
+              </a:rPr>
+              <a:t>4 · kod</a:t>
+            </a:r>
+            <a:endParaRPr lang="en-US" sz="1200" dirty="0"/>
+          </a:p>
+        </p:txBody>
+      </p:sp>
+      <p:sp>
+        <p:nvSpPr>
+          <p:cNvPr id="21" name="Text 16"/>
+          <p:cNvSpPr txBox="1"/>
+          <p:nvPr/>
+        </p:nvSpPr>
+        <p:spPr>
+          <a:xfrm>
+            <a:off x="7581900" y="2476500"/>
+            <a:ext cx="1422400" cy="508000"/>
+          </a:xfrm>
+          <a:prstGeom prst="rect">
+            <a:avLst/>
+          </a:prstGeom>
+          <a:noFill/>
+          <a:ln/>
+        </p:spPr>
+        <p:txBody>
+          <a:bodyPr wrap="square" lIns="0" tIns="0" rIns="0" bIns="0" rtlCol="0" anchor="t"/>
+          <a:lstStyle/>
+          <a:p>
+            <a:pPr algn="l" indent="0" marL="0">
+              <a:lnSpc>
+                <a:spcPct val="110000"/>
+              </a:lnSpc>
+              <a:buNone/>
+            </a:pPr>
+            <a:r>
+              <a:rPr lang="en-US" sz="1600" b="1" dirty="0">
                 <a:solidFill>
                   <a:srgbClr val="1F2937"/>
                 </a:solidFill>
@@ -6194,41 +6754,41 @@
                 <a:ea typeface="Arial" pitchFamily="34" charset="-122"/>
                 <a:cs typeface="Arial" pitchFamily="34" charset="-120"/>
               </a:rPr>
-              <a:t>FastAPI</a:t>
-            </a:r>
-            <a:endParaRPr lang="en-US" sz="1700" dirty="0"/>
-          </a:p>
-        </p:txBody>
-      </p:sp>
-      <p:sp>
-        <p:nvSpPr>
-          <p:cNvPr id="10" name="Text 7"/>
-          <p:cNvSpPr txBox="1"/>
-          <p:nvPr/>
-        </p:nvSpPr>
-        <p:spPr>
-          <a:xfrm>
-            <a:off x="3784600" y="3530600"/>
-            <a:ext cx="1879600" cy="571500"/>
-          </a:xfrm>
-          <a:prstGeom prst="rect">
-            <a:avLst/>
-          </a:prstGeom>
-          <a:noFill/>
-          <a:ln/>
-        </p:spPr>
-        <p:txBody>
-          <a:bodyPr wrap="square" lIns="0" tIns="0" rIns="0" bIns="0" rtlCol="0" anchor="t"/>
-          <a:lstStyle/>
-          <a:p>
-            <a:pPr algn="l" indent="0" marL="0">
-              <a:lnSpc>
-                <a:spcPct val="125000"/>
-              </a:lnSpc>
-              <a:buNone/>
-            </a:pPr>
-            <a:r>
-              <a:rPr lang="en-US" sz="1300" dirty="0">
+              <a:t>Sprawdzenie cytatu</a:t>
+            </a:r>
+            <a:endParaRPr lang="en-US" sz="1600" dirty="0"/>
+          </a:p>
+        </p:txBody>
+      </p:sp>
+      <p:sp>
+        <p:nvSpPr>
+          <p:cNvPr id="22" name="Text 17"/>
+          <p:cNvSpPr txBox="1"/>
+          <p:nvPr/>
+        </p:nvSpPr>
+        <p:spPr>
+          <a:xfrm>
+            <a:off x="7581900" y="3098800"/>
+            <a:ext cx="1422400" cy="863600"/>
+          </a:xfrm>
+          <a:prstGeom prst="rect">
+            <a:avLst/>
+          </a:prstGeom>
+          <a:noFill/>
+          <a:ln/>
+        </p:spPr>
+        <p:txBody>
+          <a:bodyPr wrap="square" lIns="0" tIns="0" rIns="0" bIns="0" rtlCol="0" anchor="t"/>
+          <a:lstStyle/>
+          <a:p>
+            <a:pPr algn="l" indent="0" marL="0">
+              <a:lnSpc>
+                <a:spcPct val="120000"/>
+              </a:lnSpc>
+              <a:buNone/>
+            </a:pPr>
+            <a:r>
+              <a:rPr lang="en-US" sz="1200" dirty="0">
                 <a:solidFill>
                   <a:srgbClr val="4B5563"/>
                 </a:solidFill>
@@ -6236,29 +6796,29 @@
                 <a:ea typeface="Arial" pitchFamily="34" charset="-122"/>
                 <a:cs typeface="Arial" pitchFamily="34" charset="-120"/>
               </a:rPr>
-              <a:t>funkcja Python na Vercelu</a:t>
-            </a:r>
-            <a:endParaRPr lang="en-US" sz="1300" dirty="0"/>
+              <a:t>musi być dosłownie we wcześniejszym tekście</a:t>
+            </a:r>
+            <a:endParaRPr lang="en-US" sz="1200" dirty="0"/>
           </a:p>
         </p:txBody>
       </p:sp>
       <p:pic>
         <p:nvPicPr>
-          <p:cNvPr id="11" name="Image 1" descr="preencoded.png">    </p:cNvPr>
+          <p:cNvPr id="23" name="Image 3" descr="preencoded.png">    </p:cNvPr>
           <p:cNvPicPr>
             <a:picLocks noChangeAspect="1"/>
           </p:cNvPicPr>
           <p:nvPr/>
         </p:nvPicPr>
         <p:blipFill>
-          <a:blip r:embed="rId2"/>
+          <a:blip r:embed="rId4"/>
           <a:stretch>
             <a:fillRect/>
           </a:stretch>
         </p:blipFill>
         <p:spPr>
           <a:xfrm>
-            <a:off x="5969000" y="3492500"/>
+            <a:off x="9264650" y="2921000"/>
             <a:ext cx="254000" cy="254000"/>
           </a:xfrm>
           <a:prstGeom prst="rect">
@@ -6268,18 +6828,18 @@
       </p:pic>
       <p:sp>
         <p:nvSpPr>
-          <p:cNvPr id="12" name="Shape 8"/>
+          <p:cNvPr id="24" name="Shape 18"/>
           <p:cNvSpPr/>
           <p:nvPr/>
         </p:nvSpPr>
         <p:spPr>
           <a:xfrm>
-            <a:off x="6299200" y="2921000"/>
-            <a:ext cx="2336800" cy="1397000"/>
+            <a:off x="9601200" y="2032000"/>
+            <a:ext cx="1778000" cy="2032000"/>
           </a:xfrm>
           <a:prstGeom prst="roundRect">
             <a:avLst>
-              <a:gd name="adj" fmla="val 10909"/>
+              <a:gd name="adj" fmla="val 8571"/>
             </a:avLst>
           </a:prstGeom>
           <a:solidFill>
@@ -6290,14 +6850,14 @@
       </p:sp>
       <p:sp>
         <p:nvSpPr>
-          <p:cNvPr id="13" name="Text 9"/>
-          <p:cNvSpPr txBox="1"/>
-          <p:nvPr/>
-        </p:nvSpPr>
-        <p:spPr>
-          <a:xfrm>
-            <a:off x="6527800" y="3149600"/>
-            <a:ext cx="1879600" cy="292100"/>
+          <p:cNvPr id="25" name="Text 19"/>
+          <p:cNvSpPr txBox="1"/>
+          <p:nvPr/>
+        </p:nvSpPr>
+        <p:spPr>
+          <a:xfrm>
+            <a:off x="9779000" y="2209800"/>
+            <a:ext cx="1422400" cy="203200"/>
           </a:xfrm>
           <a:prstGeom prst="rect">
             <a:avLst/>
@@ -6316,7 +6876,49 @@
               <a:buNone/>
             </a:pPr>
             <a:r>
-              <a:rPr lang="en-US" sz="1700" b="1" dirty="0">
+              <a:rPr lang="en-US" sz="1200" b="1" dirty="0">
+                <a:solidFill>
+                  <a:srgbClr val="6D28D9"/>
+                </a:solidFill>
+                <a:latin typeface="Arial" pitchFamily="34" charset="0"/>
+                <a:ea typeface="Arial" pitchFamily="34" charset="-122"/>
+                <a:cs typeface="Arial" pitchFamily="34" charset="-120"/>
+              </a:rPr>
+              <a:t>5 · AI</a:t>
+            </a:r>
+            <a:endParaRPr lang="en-US" sz="1200" dirty="0"/>
+          </a:p>
+        </p:txBody>
+      </p:sp>
+      <p:sp>
+        <p:nvSpPr>
+          <p:cNvPr id="26" name="Text 20"/>
+          <p:cNvSpPr txBox="1"/>
+          <p:nvPr/>
+        </p:nvSpPr>
+        <p:spPr>
+          <a:xfrm>
+            <a:off x="9779000" y="2476500"/>
+            <a:ext cx="1422400" cy="508000"/>
+          </a:xfrm>
+          <a:prstGeom prst="rect">
+            <a:avLst/>
+          </a:prstGeom>
+          <a:noFill/>
+          <a:ln/>
+        </p:spPr>
+        <p:txBody>
+          <a:bodyPr wrap="square" lIns="0" tIns="0" rIns="0" bIns="0" rtlCol="0" anchor="t"/>
+          <a:lstStyle/>
+          <a:p>
+            <a:pPr algn="l" indent="0" marL="0">
+              <a:lnSpc>
+                <a:spcPct val="110000"/>
+              </a:lnSpc>
+              <a:buNone/>
+            </a:pPr>
+            <a:r>
+              <a:rPr lang="en-US" sz="1600" b="1" dirty="0">
                 <a:solidFill>
                   <a:srgbClr val="1F2937"/>
                 </a:solidFill>
@@ -6324,41 +6926,41 @@
                 <a:ea typeface="Arial" pitchFamily="34" charset="-122"/>
                 <a:cs typeface="Arial" pitchFamily="34" charset="-120"/>
               </a:rPr>
-              <a:t>Groq</a:t>
-            </a:r>
-            <a:endParaRPr lang="en-US" sz="1700" dirty="0"/>
-          </a:p>
-        </p:txBody>
-      </p:sp>
-      <p:sp>
-        <p:nvSpPr>
-          <p:cNvPr id="14" name="Text 10"/>
-          <p:cNvSpPr txBox="1"/>
-          <p:nvPr/>
-        </p:nvSpPr>
-        <p:spPr>
-          <a:xfrm>
-            <a:off x="6527800" y="3530600"/>
-            <a:ext cx="1879600" cy="571500"/>
-          </a:xfrm>
-          <a:prstGeom prst="rect">
-            <a:avLst/>
-          </a:prstGeom>
-          <a:noFill/>
-          <a:ln/>
-        </p:spPr>
-        <p:txBody>
-          <a:bodyPr wrap="square" lIns="0" tIns="0" rIns="0" bIns="0" rtlCol="0" anchor="t"/>
-          <a:lstStyle/>
-          <a:p>
-            <a:pPr algn="l" indent="0" marL="0">
-              <a:lnSpc>
-                <a:spcPct val="125000"/>
-              </a:lnSpc>
-              <a:buNone/>
-            </a:pPr>
-            <a:r>
-              <a:rPr lang="en-US" sz="1300" dirty="0">
+              <a:t>Narrator</a:t>
+            </a:r>
+            <a:endParaRPr lang="en-US" sz="1600" dirty="0"/>
+          </a:p>
+        </p:txBody>
+      </p:sp>
+      <p:sp>
+        <p:nvSpPr>
+          <p:cNvPr id="27" name="Text 21"/>
+          <p:cNvSpPr txBox="1"/>
+          <p:nvPr/>
+        </p:nvSpPr>
+        <p:spPr>
+          <a:xfrm>
+            <a:off x="9779000" y="3098800"/>
+            <a:ext cx="1422400" cy="863600"/>
+          </a:xfrm>
+          <a:prstGeom prst="rect">
+            <a:avLst/>
+          </a:prstGeom>
+          <a:noFill/>
+          <a:ln/>
+        </p:spPr>
+        <p:txBody>
+          <a:bodyPr wrap="square" lIns="0" tIns="0" rIns="0" bIns="0" rtlCol="0" anchor="t"/>
+          <a:lstStyle/>
+          <a:p>
+            <a:pPr algn="l" indent="0" marL="0">
+              <a:lnSpc>
+                <a:spcPct val="120000"/>
+              </a:lnSpc>
+              <a:buNone/>
+            </a:pPr>
+            <a:r>
+              <a:rPr lang="en-US" sz="1200" dirty="0">
                 <a:solidFill>
                   <a:srgbClr val="4B5563"/>
                 </a:solidFill>
@@ -6366,58 +6968,76 @@
                 <a:ea typeface="Arial" pitchFamily="34" charset="-122"/>
                 <a:cs typeface="Arial" pitchFamily="34" charset="-120"/>
               </a:rPr>
-              <a:t>za interfejsem LLMProvider</a:t>
-            </a:r>
-            <a:endParaRPr lang="en-US" sz="1300" dirty="0"/>
-          </a:p>
-        </p:txBody>
-      </p:sp>
-      <p:pic>
-        <p:nvPicPr>
-          <p:cNvPr id="15" name="Image 2" descr="preencoded.png">    </p:cNvPr>
-          <p:cNvPicPr>
-            <a:picLocks noChangeAspect="1"/>
-          </p:cNvPicPr>
-          <p:nvPr/>
-        </p:nvPicPr>
-        <p:blipFill>
-          <a:blip r:embed="rId3"/>
-          <a:stretch>
-            <a:fillRect/>
-          </a:stretch>
-        </p:blipFill>
-        <p:spPr>
-          <a:xfrm>
-            <a:off x="8712200" y="3492500"/>
-            <a:ext cx="254000" cy="254000"/>
-          </a:xfrm>
-          <a:prstGeom prst="rect">
-            <a:avLst/>
-          </a:prstGeom>
-        </p:spPr>
-      </p:pic>
-      <p:sp>
-        <p:nvSpPr>
-          <p:cNvPr id="16" name="Shape 11"/>
+              <a:t>dopisuje ciąg dalszy, pałeczka idzie dalej</a:t>
+            </a:r>
+            <a:endParaRPr lang="en-US" sz="1200" dirty="0"/>
+          </a:p>
+        </p:txBody>
+      </p:sp>
+      <p:sp>
+        <p:nvSpPr>
+          <p:cNvPr id="28" name="Text 22"/>
+          <p:cNvSpPr txBox="1"/>
+          <p:nvPr/>
+        </p:nvSpPr>
+        <p:spPr>
+          <a:xfrm>
+            <a:off x="812800" y="4318000"/>
+            <a:ext cx="10566400" cy="215900"/>
+          </a:xfrm>
+          <a:prstGeom prst="rect">
+            <a:avLst/>
+          </a:prstGeom>
+          <a:noFill/>
+          <a:ln/>
+        </p:spPr>
+        <p:txBody>
+          <a:bodyPr wrap="square" lIns="0" tIns="0" rIns="0" bIns="0" rtlCol="0" anchor="t"/>
+          <a:lstStyle/>
+          <a:p>
+            <a:pPr algn="l" indent="0" marL="0">
+              <a:lnSpc>
+                <a:spcPct val="110000"/>
+              </a:lnSpc>
+              <a:buNone/>
+            </a:pPr>
+            <a:r>
+              <a:rPr lang="en-US" sz="1200" b="1" spc="200" kern="0" dirty="0">
+                <a:solidFill>
+                  <a:srgbClr val="6B7280"/>
+                </a:solidFill>
+                <a:latin typeface="Arial" pitchFamily="34" charset="0"/>
+                <a:ea typeface="Arial" pitchFamily="34" charset="-122"/>
+                <a:cs typeface="Arial" pitchFamily="34" charset="-120"/>
+              </a:rPr>
+              <a:t>ZASADY KAŻDEGO WYWOŁANIA AI</a:t>
+            </a:r>
+            <a:endParaRPr lang="en-US" sz="1200" dirty="0"/>
+          </a:p>
+        </p:txBody>
+      </p:sp>
+      <p:sp>
+        <p:nvSpPr>
+          <p:cNvPr id="29" name="Shape 23"/>
           <p:cNvSpPr/>
           <p:nvPr/>
         </p:nvSpPr>
         <p:spPr>
           <a:xfrm>
-            <a:off x="9042400" y="2921000"/>
-            <a:ext cx="2336800" cy="1397000"/>
+            <a:off x="812800" y="4660900"/>
+            <a:ext cx="2489200" cy="1384300"/>
           </a:xfrm>
           <a:prstGeom prst="roundRect">
             <a:avLst>
-              <a:gd name="adj" fmla="val 10909"/>
+              <a:gd name="adj" fmla="val 11009"/>
             </a:avLst>
           </a:prstGeom>
           <a:solidFill>
-            <a:srgbClr val="FFF7ED"/>
+            <a:srgbClr val="FFFFFF"/>
           </a:solidFill>
           <a:ln w="19050">
             <a:solidFill>
-              <a:srgbClr val="FDE4CC"/>
+              <a:srgbClr val="E9D5FF"/>
             </a:solidFill>
             <a:prstDash val="solid"/>
           </a:ln>
@@ -6425,14 +7045,14 @@
       </p:sp>
       <p:sp>
         <p:nvSpPr>
-          <p:cNvPr id="17" name="Text 12"/>
-          <p:cNvSpPr txBox="1"/>
-          <p:nvPr/>
-        </p:nvSpPr>
-        <p:spPr>
-          <a:xfrm>
-            <a:off x="9271000" y="3149600"/>
-            <a:ext cx="1879600" cy="292100"/>
+          <p:cNvPr id="30" name="Text 24"/>
+          <p:cNvSpPr txBox="1"/>
+          <p:nvPr/>
+        </p:nvSpPr>
+        <p:spPr>
+          <a:xfrm>
+            <a:off x="990600" y="4838700"/>
+            <a:ext cx="2133600" cy="254000"/>
           </a:xfrm>
           <a:prstGeom prst="rect">
             <a:avLst/>
@@ -6451,7 +7071,7 @@
               <a:buNone/>
             </a:pPr>
             <a:r>
-              <a:rPr lang="en-US" sz="1700" b="1" dirty="0">
+              <a:rPr lang="en-US" sz="1500" b="1" dirty="0">
                 <a:solidFill>
                   <a:srgbClr val="1F2937"/>
                 </a:solidFill>
@@ -6459,41 +7079,41 @@
                 <a:ea typeface="Arial" pitchFamily="34" charset="-122"/>
                 <a:cs typeface="Arial" pitchFamily="34" charset="-120"/>
               </a:rPr>
-              <a:t>Postgres</a:t>
-            </a:r>
-            <a:endParaRPr lang="en-US" sz="1700" dirty="0"/>
-          </a:p>
-        </p:txBody>
-      </p:sp>
-      <p:sp>
-        <p:nvSpPr>
-          <p:cNvPr id="18" name="Text 13"/>
-          <p:cNvSpPr txBox="1"/>
-          <p:nvPr/>
-        </p:nvSpPr>
-        <p:spPr>
-          <a:xfrm>
-            <a:off x="9271000" y="3530600"/>
-            <a:ext cx="1879600" cy="571500"/>
-          </a:xfrm>
-          <a:prstGeom prst="rect">
-            <a:avLst/>
-          </a:prstGeom>
-          <a:noFill/>
-          <a:ln/>
-        </p:spPr>
-        <p:txBody>
-          <a:bodyPr wrap="square" lIns="0" tIns="0" rIns="0" bIns="0" rtlCol="0" anchor="t"/>
-          <a:lstStyle/>
-          <a:p>
-            <a:pPr algn="l" indent="0" marL="0">
-              <a:lnSpc>
-                <a:spcPct val="125000"/>
-              </a:lnSpc>
-              <a:buNone/>
-            </a:pPr>
-            <a:r>
-              <a:rPr lang="en-US" sz="1300" dirty="0">
+              <a:t>Prompt na krok</a:t>
+            </a:r>
+            <a:endParaRPr lang="en-US" sz="1500" dirty="0"/>
+          </a:p>
+        </p:txBody>
+      </p:sp>
+      <p:sp>
+        <p:nvSpPr>
+          <p:cNvPr id="31" name="Text 25"/>
+          <p:cNvSpPr txBox="1"/>
+          <p:nvPr/>
+        </p:nvSpPr>
+        <p:spPr>
+          <a:xfrm>
+            <a:off x="990600" y="5168900"/>
+            <a:ext cx="2133600" cy="762000"/>
+          </a:xfrm>
+          <a:prstGeom prst="rect">
+            <a:avLst/>
+          </a:prstGeom>
+          <a:noFill/>
+          <a:ln/>
+        </p:spPr>
+        <p:txBody>
+          <a:bodyPr wrap="square" lIns="0" tIns="0" rIns="0" bIns="0" rtlCol="0" anchor="t"/>
+          <a:lstStyle/>
+          <a:p>
+            <a:pPr algn="l" indent="0" marL="0">
+              <a:lnSpc>
+                <a:spcPct val="120000"/>
+              </a:lnSpc>
+              <a:buNone/>
+            </a:pPr>
+            <a:r>
+              <a:rPr lang="en-US" sz="1200" dirty="0">
                 <a:solidFill>
                   <a:srgbClr val="4B5563"/>
                 </a:solidFill>
@@ -6501,9 +7121,342 @@
                 <a:ea typeface="Arial" pitchFamily="34" charset="-122"/>
                 <a:cs typeface="Arial" pitchFamily="34" charset="-120"/>
               </a:rPr>
-              <a:t>Supabase; lokalnie SQLite</a:t>
-            </a:r>
-            <a:endParaRPr lang="en-US" sz="1300" dirty="0"/>
+              <a:t>osobny prompt dla każdego zadania, w plikach .md poza kodem</a:t>
+            </a:r>
+            <a:endParaRPr lang="en-US" sz="1200" dirty="0"/>
+          </a:p>
+        </p:txBody>
+      </p:sp>
+      <p:sp>
+        <p:nvSpPr>
+          <p:cNvPr id="32" name="Shape 26"/>
+          <p:cNvSpPr/>
+          <p:nvPr/>
+        </p:nvSpPr>
+        <p:spPr>
+          <a:xfrm>
+            <a:off x="3505200" y="4660900"/>
+            <a:ext cx="2489200" cy="1384300"/>
+          </a:xfrm>
+          <a:prstGeom prst="roundRect">
+            <a:avLst>
+              <a:gd name="adj" fmla="val 11009"/>
+            </a:avLst>
+          </a:prstGeom>
+          <a:solidFill>
+            <a:srgbClr val="FFFFFF"/>
+          </a:solidFill>
+          <a:ln w="19050">
+            <a:solidFill>
+              <a:srgbClr val="E9D5FF"/>
+            </a:solidFill>
+            <a:prstDash val="solid"/>
+          </a:ln>
+        </p:spPr>
+      </p:sp>
+      <p:sp>
+        <p:nvSpPr>
+          <p:cNvPr id="33" name="Text 27"/>
+          <p:cNvSpPr txBox="1"/>
+          <p:nvPr/>
+        </p:nvSpPr>
+        <p:spPr>
+          <a:xfrm>
+            <a:off x="3683000" y="4838700"/>
+            <a:ext cx="2133600" cy="254000"/>
+          </a:xfrm>
+          <a:prstGeom prst="rect">
+            <a:avLst/>
+          </a:prstGeom>
+          <a:noFill/>
+          <a:ln/>
+        </p:spPr>
+        <p:txBody>
+          <a:bodyPr wrap="square" lIns="0" tIns="0" rIns="0" bIns="0" rtlCol="0" anchor="t"/>
+          <a:lstStyle/>
+          <a:p>
+            <a:pPr algn="l" indent="0" marL="0">
+              <a:lnSpc>
+                <a:spcPct val="110000"/>
+              </a:lnSpc>
+              <a:buNone/>
+            </a:pPr>
+            <a:r>
+              <a:rPr lang="en-US" sz="1500" b="1" dirty="0">
+                <a:solidFill>
+                  <a:srgbClr val="1F2937"/>
+                </a:solidFill>
+                <a:latin typeface="Arial" pitchFamily="34" charset="0"/>
+                <a:ea typeface="Arial" pitchFamily="34" charset="-122"/>
+                <a:cs typeface="Arial" pitchFamily="34" charset="-120"/>
+              </a:rPr>
+              <a:t>JSON + schemat</a:t>
+            </a:r>
+            <a:endParaRPr lang="en-US" sz="1500" dirty="0"/>
+          </a:p>
+        </p:txBody>
+      </p:sp>
+      <p:sp>
+        <p:nvSpPr>
+          <p:cNvPr id="34" name="Text 28"/>
+          <p:cNvSpPr txBox="1"/>
+          <p:nvPr/>
+        </p:nvSpPr>
+        <p:spPr>
+          <a:xfrm>
+            <a:off x="3683000" y="5168900"/>
+            <a:ext cx="2133600" cy="762000"/>
+          </a:xfrm>
+          <a:prstGeom prst="rect">
+            <a:avLst/>
+          </a:prstGeom>
+          <a:noFill/>
+          <a:ln/>
+        </p:spPr>
+        <p:txBody>
+          <a:bodyPr wrap="square" lIns="0" tIns="0" rIns="0" bIns="0" rtlCol="0" anchor="t"/>
+          <a:lstStyle/>
+          <a:p>
+            <a:pPr algn="l" indent="0" marL="0">
+              <a:lnSpc>
+                <a:spcPct val="120000"/>
+              </a:lnSpc>
+              <a:buNone/>
+            </a:pPr>
+            <a:r>
+              <a:rPr lang="en-US" sz="1200" dirty="0">
+                <a:solidFill>
+                  <a:srgbClr val="4B5563"/>
+                </a:solidFill>
+                <a:latin typeface="Arial" pitchFamily="34" charset="0"/>
+                <a:ea typeface="Arial" pitchFamily="34" charset="-122"/>
+                <a:cs typeface="Arial" pitchFamily="34" charset="-120"/>
+              </a:rPr>
+              <a:t>każda odpowiedź walidowana; błąd → jedno ponowienie</a:t>
+            </a:r>
+            <a:endParaRPr lang="en-US" sz="1200" dirty="0"/>
+          </a:p>
+        </p:txBody>
+      </p:sp>
+      <p:sp>
+        <p:nvSpPr>
+          <p:cNvPr id="35" name="Shape 29"/>
+          <p:cNvSpPr/>
+          <p:nvPr/>
+        </p:nvSpPr>
+        <p:spPr>
+          <a:xfrm>
+            <a:off x="6197600" y="4660900"/>
+            <a:ext cx="2489200" cy="1384300"/>
+          </a:xfrm>
+          <a:prstGeom prst="roundRect">
+            <a:avLst>
+              <a:gd name="adj" fmla="val 11009"/>
+            </a:avLst>
+          </a:prstGeom>
+          <a:solidFill>
+            <a:srgbClr val="FFFFFF"/>
+          </a:solidFill>
+          <a:ln w="19050">
+            <a:solidFill>
+              <a:srgbClr val="E9D5FF"/>
+            </a:solidFill>
+            <a:prstDash val="solid"/>
+          </a:ln>
+        </p:spPr>
+      </p:sp>
+      <p:sp>
+        <p:nvSpPr>
+          <p:cNvPr id="36" name="Text 30"/>
+          <p:cNvSpPr txBox="1"/>
+          <p:nvPr/>
+        </p:nvSpPr>
+        <p:spPr>
+          <a:xfrm>
+            <a:off x="6375400" y="4838700"/>
+            <a:ext cx="2133600" cy="254000"/>
+          </a:xfrm>
+          <a:prstGeom prst="rect">
+            <a:avLst/>
+          </a:prstGeom>
+          <a:noFill/>
+          <a:ln/>
+        </p:spPr>
+        <p:txBody>
+          <a:bodyPr wrap="square" lIns="0" tIns="0" rIns="0" bIns="0" rtlCol="0" anchor="t"/>
+          <a:lstStyle/>
+          <a:p>
+            <a:pPr algn="l" indent="0" marL="0">
+              <a:lnSpc>
+                <a:spcPct val="110000"/>
+              </a:lnSpc>
+              <a:buNone/>
+            </a:pPr>
+            <a:r>
+              <a:rPr lang="en-US" sz="1500" b="1" dirty="0">
+                <a:solidFill>
+                  <a:srgbClr val="1F2937"/>
+                </a:solidFill>
+                <a:latin typeface="Arial" pitchFamily="34" charset="0"/>
+                <a:ea typeface="Arial" pitchFamily="34" charset="-122"/>
+                <a:cs typeface="Arial" pitchFamily="34" charset="-120"/>
+              </a:rPr>
+              <a:t>Model do zadania</a:t>
+            </a:r>
+            <a:endParaRPr lang="en-US" sz="1500" dirty="0"/>
+          </a:p>
+        </p:txBody>
+      </p:sp>
+      <p:sp>
+        <p:nvSpPr>
+          <p:cNvPr id="37" name="Text 31"/>
+          <p:cNvSpPr txBox="1"/>
+          <p:nvPr/>
+        </p:nvSpPr>
+        <p:spPr>
+          <a:xfrm>
+            <a:off x="6375400" y="5168900"/>
+            <a:ext cx="2133600" cy="762000"/>
+          </a:xfrm>
+          <a:prstGeom prst="rect">
+            <a:avLst/>
+          </a:prstGeom>
+          <a:noFill/>
+          <a:ln/>
+        </p:spPr>
+        <p:txBody>
+          <a:bodyPr wrap="square" lIns="0" tIns="0" rIns="0" bIns="0" rtlCol="0" anchor="t"/>
+          <a:lstStyle/>
+          <a:p>
+            <a:pPr algn="l" indent="0" marL="0">
+              <a:lnSpc>
+                <a:spcPct val="120000"/>
+              </a:lnSpc>
+              <a:buNone/>
+            </a:pPr>
+            <a:r>
+              <a:rPr lang="en-US" sz="1200" dirty="0">
+                <a:solidFill>
+                  <a:srgbClr val="4B5563"/>
+                </a:solidFill>
+                <a:latin typeface="Arial" pitchFamily="34" charset="0"/>
+                <a:ea typeface="Arial" pitchFamily="34" charset="-122"/>
+                <a:cs typeface="Arial" pitchFamily="34" charset="-120"/>
+              </a:rPr>
+              <a:t>osobny model bezpieczeństwa do moderacji, większy do pisania i oceny</a:t>
+            </a:r>
+            <a:endParaRPr lang="en-US" sz="1200" dirty="0"/>
+          </a:p>
+        </p:txBody>
+      </p:sp>
+      <p:sp>
+        <p:nvSpPr>
+          <p:cNvPr id="38" name="Shape 32"/>
+          <p:cNvSpPr/>
+          <p:nvPr/>
+        </p:nvSpPr>
+        <p:spPr>
+          <a:xfrm>
+            <a:off x="8890000" y="4660900"/>
+            <a:ext cx="2489200" cy="1384300"/>
+          </a:xfrm>
+          <a:prstGeom prst="roundRect">
+            <a:avLst>
+              <a:gd name="adj" fmla="val 11009"/>
+            </a:avLst>
+          </a:prstGeom>
+          <a:solidFill>
+            <a:srgbClr val="FFFFFF"/>
+          </a:solidFill>
+          <a:ln w="19050">
+            <a:solidFill>
+              <a:srgbClr val="E9D5FF"/>
+            </a:solidFill>
+            <a:prstDash val="solid"/>
+          </a:ln>
+        </p:spPr>
+      </p:sp>
+      <p:sp>
+        <p:nvSpPr>
+          <p:cNvPr id="39" name="Text 33"/>
+          <p:cNvSpPr txBox="1"/>
+          <p:nvPr/>
+        </p:nvSpPr>
+        <p:spPr>
+          <a:xfrm>
+            <a:off x="9067800" y="4838700"/>
+            <a:ext cx="2133600" cy="254000"/>
+          </a:xfrm>
+          <a:prstGeom prst="rect">
+            <a:avLst/>
+          </a:prstGeom>
+          <a:noFill/>
+          <a:ln/>
+        </p:spPr>
+        <p:txBody>
+          <a:bodyPr wrap="square" lIns="0" tIns="0" rIns="0" bIns="0" rtlCol="0" anchor="t"/>
+          <a:lstStyle/>
+          <a:p>
+            <a:pPr algn="l" indent="0" marL="0">
+              <a:lnSpc>
+                <a:spcPct val="110000"/>
+              </a:lnSpc>
+              <a:buNone/>
+            </a:pPr>
+            <a:r>
+              <a:rPr lang="en-US" sz="1500" b="1" dirty="0">
+                <a:solidFill>
+                  <a:srgbClr val="1F2937"/>
+                </a:solidFill>
+                <a:latin typeface="Arial" pitchFamily="34" charset="0"/>
+                <a:ea typeface="Arial" pitchFamily="34" charset="-122"/>
+                <a:cs typeface="Arial" pitchFamily="34" charset="-120"/>
+              </a:rPr>
+              <a:t>Wymienny dostawca</a:t>
+            </a:r>
+            <a:endParaRPr lang="en-US" sz="1500" dirty="0"/>
+          </a:p>
+        </p:txBody>
+      </p:sp>
+      <p:sp>
+        <p:nvSpPr>
+          <p:cNvPr id="40" name="Text 34"/>
+          <p:cNvSpPr txBox="1"/>
+          <p:nvPr/>
+        </p:nvSpPr>
+        <p:spPr>
+          <a:xfrm>
+            <a:off x="9067800" y="5168900"/>
+            <a:ext cx="2133600" cy="762000"/>
+          </a:xfrm>
+          <a:prstGeom prst="rect">
+            <a:avLst/>
+          </a:prstGeom>
+          <a:noFill/>
+          <a:ln/>
+        </p:spPr>
+        <p:txBody>
+          <a:bodyPr wrap="square" lIns="0" tIns="0" rIns="0" bIns="0" rtlCol="0" anchor="t"/>
+          <a:lstStyle/>
+          <a:p>
+            <a:pPr algn="l" indent="0" marL="0">
+              <a:lnSpc>
+                <a:spcPct val="120000"/>
+              </a:lnSpc>
+              <a:buNone/>
+            </a:pPr>
+            <a:r>
+              <a:rPr lang="en-US" sz="1200" dirty="0">
+                <a:solidFill>
+                  <a:srgbClr val="4B5563"/>
+                </a:solidFill>
+                <a:latin typeface="Arial" pitchFamily="34" charset="0"/>
+                <a:ea typeface="Arial" pitchFamily="34" charset="-122"/>
+                <a:cs typeface="Arial" pitchFamily="34" charset="-120"/>
+              </a:rPr>
+              <a:t>Groq za interfejsem LLMProvider; bez sieci MockProvider</a:t>
+            </a:r>
+            <a:endParaRPr lang="en-US" sz="1200" dirty="0"/>
           </a:p>
         </p:txBody>
       </p:sp>

</xml_diff>

<commit_message>
Prezentacja: link do repo github.com/Drop-the-Base/sztafeta-slow
Co-Authored-By: Claude Opus 5.5 <noreply@anthropic.com>
</commit_message>
<xml_diff>
--- a/docs/pitch/Sztafeta-Slow.pptx
+++ b/docs/pitch/Sztafeta-Slow.pptx
@@ -116,28 +116,28 @@
   <p:extLst>
     <p:ext uri="{521415D9-36F7-43E2-AB2F-B90AF26B5E84}">
       <p14:sectionLst xmlns:p14="http://schemas.microsoft.com/office/powerpoint/2010/main">
-        <p14:section name="Problem" id="{640ef642-8def-861a-7a75-78dd1b5f25f4}">
+        <p14:section name="Problem" id="{971a7c0f-3584-a378-a137-63b1633a5252}">
           <p14:sldIdLst>
             <p14:sldId id="256"/>
             <p14:sldId id="257"/>
             <p14:sldId id="258"/>
           </p14:sldIdLst>
         </p14:section>
-        <p14:section name="Rozwiązanie" id="{6b58cffb-2082-8389-57dc-8f9204f8ae78}">
+        <p14:section name="Rozwiązanie" id="{0bff5496-fa0c-8b5a-efb1-29894a8f849f}">
           <p14:sldIdLst>
             <p14:sldId id="259"/>
             <p14:sldId id="260"/>
             <p14:sldId id="261"/>
           </p14:sldIdLst>
         </p14:section>
-        <p14:section name="Jak działa AI" id="{920bffc1-159c-5425-2683-442c9034cb0f}">
+        <p14:section name="Jak działa AI" id="{7f014ce0-b98f-fc43-c5e0-dffc0e784fc6}">
           <p14:sldIdLst>
             <p14:sldId id="262"/>
             <p14:sldId id="263"/>
             <p14:sldId id="264"/>
           </p14:sldIdLst>
         </p14:section>
-        <p14:section name="Zespół i demo" id="{1c8b7a29-9629-9285-5dcd-0a3ad9dcd574}">
+        <p14:section name="Zespół i demo" id="{5c3a3435-9e6f-701c-626f-394dde707b58}">
           <p14:sldIdLst>
             <p14:sldId id="265"/>
           </p14:sldIdLst>
@@ -2207,7 +2207,7 @@
                 <a:ea typeface="Arial" pitchFamily="34" charset="-122"/>
                 <a:cs typeface="Arial" pitchFamily="34" charset="-120"/>
               </a:rPr>
-              <a:t>github.com/Drop-the-Base/dezanalfabetyzator</a:t>
+              <a:t>github.com/Drop-the-Base/sztafeta-slow</a:t>
             </a:r>
             <a:endParaRPr lang="en-US" sz="1400" dirty="0"/>
           </a:p>
@@ -2323,7 +2323,27 @@
                 <a:ea typeface="Arial" pitchFamily="34" charset="-122"/>
                 <a:cs typeface="Arial" pitchFamily="34" charset="-120"/>
               </a:rPr>
-              <a:t>Wysoko w rankingu, ale co czwarty 15-latek nie rozumie tego, co czyta</a:t>
+              <a:t>Wysoko w rankingu, ale co czwarty</a:t>
+            </a:r>
+            <a:endParaRPr lang="en-US" sz="3600" dirty="0"/>
+          </a:p>
+          <a:p>
+            <a:pPr algn="l" indent="0" marL="0">
+              <a:lnSpc>
+                <a:spcPct val="110000"/>
+              </a:lnSpc>
+              <a:buNone/>
+            </a:pPr>
+            <a:r>
+              <a:rPr lang="en-US" sz="3600" b="1" dirty="0">
+                <a:solidFill>
+                  <a:srgbClr val="1F2937"/>
+                </a:solidFill>
+                <a:latin typeface="Arial" pitchFamily="34" charset="0"/>
+                <a:ea typeface="Arial" pitchFamily="34" charset="-122"/>
+                <a:cs typeface="Arial" pitchFamily="34" charset="-120"/>
+              </a:rPr>
+              <a:t>15-latek nie rozumie tego, co czyta</a:t>
             </a:r>
             <a:endParaRPr lang="en-US" sz="3600" dirty="0"/>
           </a:p>

</xml_diff>